<commit_message>
Deck 8: add fade transitions and automatic fade-in builds
Applied tools/polish.py: 0.7 s fade between slides; diagram groups, pictures and captions fade in automatically in order, with no clicks. Titles, tag chips, slide numbers and credits stay in place. Content is unchanged.

Co-Authored-By: Claude Sonnet 5.5 <noreply@anthropic.com>
</commit_message>
<xml_diff>
--- a/Reporting/Claude Presents/Deck8_AfterLaunch_LateSteam/After_Launch_Late_Steam_Driving_and_Prestige_Explained.pptx
+++ b/Reporting/Claude Presents/Deck8_AfterLaunch_LateSteam/After_Launch_Late_Steam_Driving_and_Prestige_Explained.pptx
@@ -3337,6 +3337,174 @@
   <p:clrMapOvr>
     <a:masterClrMapping/>
   </p:clrMapOvr>
+  <mc:AlternateContent xmlns:mc="http://schemas.openxmlformats.org/markup-compatibility/2006">
+    <mc:Choice xmlns:p14="http://schemas.microsoft.com/office/powerpoint/2010/main" Requires="p14">
+      <p:transition spd="med" p14:dur="700">
+        <p:fade/>
+      </p:transition>
+    </mc:Choice>
+    <mc:Fallback>
+      <p:transition spd="med">
+        <p:fade/>
+      </p:transition>
+    </mc:Fallback>
+  </mc:AlternateContent>
+  <p:timing>
+    <p:tnLst>
+      <p:par>
+        <p:cTn id="1" dur="indefinite" restart="never" nodeType="tmRoot">
+          <p:childTnLst>
+            <p:seq concurrent="1" nextAc="seek">
+              <p:cTn id="2" dur="indefinite" nodeType="mainSeq">
+                <p:childTnLst>
+                  <p:par>
+                    <p:cTn id="3" fill="hold">
+                      <p:stCondLst>
+                        <p:cond delay="indefinite"/>
+                        <p:cond evt="onBegin" delay="0">
+                          <p:tn val="2"/>
+                        </p:cond>
+                      </p:stCondLst>
+                      <p:childTnLst>
+                        <p:par>
+                          <p:cTn id="4" fill="hold">
+                            <p:stCondLst>
+                              <p:cond delay="0"/>
+                            </p:stCondLst>
+                            <p:childTnLst>
+                              <p:par>
+                                <p:cTn id="5" presetID="10" presetClass="entr" presetSubtype="0" fill="hold" nodeType="afterEffect">
+                                  <p:stCondLst>
+                                    <p:cond delay="0"/>
+                                  </p:stCondLst>
+                                  <p:childTnLst>
+                                    <p:set>
+                                      <p:cBhvr>
+                                        <p:cTn id="6" dur="1" fill="hold">
+                                          <p:stCondLst>
+                                            <p:cond delay="0"/>
+                                          </p:stCondLst>
+                                        </p:cTn>
+                                        <p:tgtEl>
+                                          <p:spTgt spid="3"/>
+                                        </p:tgtEl>
+                                        <p:attrNameLst>
+                                          <p:attrName>style.visibility</p:attrName>
+                                        </p:attrNameLst>
+                                      </p:cBhvr>
+                                      <p:to>
+                                        <p:strVal val="visible"/>
+                                      </p:to>
+                                    </p:set>
+                                    <p:animEffect transition="in" filter="fade">
+                                      <p:cBhvr>
+                                        <p:cTn id="7" dur="500"/>
+                                        <p:tgtEl>
+                                          <p:spTgt spid="3"/>
+                                        </p:tgtEl>
+                                      </p:cBhvr>
+                                    </p:animEffect>
+                                  </p:childTnLst>
+                                </p:cTn>
+                              </p:par>
+                              <p:par>
+                                <p:cTn id="8" presetID="10" presetClass="entr" presetSubtype="0" fill="hold" nodeType="withEffect">
+                                  <p:stCondLst>
+                                    <p:cond delay="300"/>
+                                  </p:stCondLst>
+                                  <p:childTnLst>
+                                    <p:set>
+                                      <p:cBhvr>
+                                        <p:cTn id="9" dur="1" fill="hold">
+                                          <p:stCondLst>
+                                            <p:cond delay="0"/>
+                                          </p:stCondLst>
+                                        </p:cTn>
+                                        <p:tgtEl>
+                                          <p:spTgt spid="5"/>
+                                        </p:tgtEl>
+                                        <p:attrNameLst>
+                                          <p:attrName>style.visibility</p:attrName>
+                                        </p:attrNameLst>
+                                      </p:cBhvr>
+                                      <p:to>
+                                        <p:strVal val="visible"/>
+                                      </p:to>
+                                    </p:set>
+                                    <p:animEffect transition="in" filter="fade">
+                                      <p:cBhvr>
+                                        <p:cTn id="10" dur="500"/>
+                                        <p:tgtEl>
+                                          <p:spTgt spid="5"/>
+                                        </p:tgtEl>
+                                      </p:cBhvr>
+                                    </p:animEffect>
+                                  </p:childTnLst>
+                                </p:cTn>
+                              </p:par>
+                              <p:par>
+                                <p:cTn id="11" presetID="10" presetClass="entr" presetSubtype="0" fill="hold" nodeType="withEffect">
+                                  <p:stCondLst>
+                                    <p:cond delay="600"/>
+                                  </p:stCondLst>
+                                  <p:childTnLst>
+                                    <p:set>
+                                      <p:cBhvr>
+                                        <p:cTn id="12" dur="1" fill="hold">
+                                          <p:stCondLst>
+                                            <p:cond delay="0"/>
+                                          </p:stCondLst>
+                                        </p:cTn>
+                                        <p:tgtEl>
+                                          <p:spTgt spid="6"/>
+                                        </p:tgtEl>
+                                        <p:attrNameLst>
+                                          <p:attrName>style.visibility</p:attrName>
+                                        </p:attrNameLst>
+                                      </p:cBhvr>
+                                      <p:to>
+                                        <p:strVal val="visible"/>
+                                      </p:to>
+                                    </p:set>
+                                    <p:animEffect transition="in" filter="fade">
+                                      <p:cBhvr>
+                                        <p:cTn id="13" dur="500"/>
+                                        <p:tgtEl>
+                                          <p:spTgt spid="6"/>
+                                        </p:tgtEl>
+                                      </p:cBhvr>
+                                    </p:animEffect>
+                                  </p:childTnLst>
+                                </p:cTn>
+                              </p:par>
+                            </p:childTnLst>
+                          </p:cTn>
+                        </p:par>
+                      </p:childTnLst>
+                    </p:cTn>
+                  </p:par>
+                </p:childTnLst>
+              </p:cTn>
+              <p:prevCondLst>
+                <p:cond evt="onPrev" delay="0">
+                  <p:tgtEl>
+                    <p:sldTgt/>
+                  </p:tgtEl>
+                </p:cond>
+              </p:prevCondLst>
+              <p:nextCondLst>
+                <p:cond evt="onNext" delay="0">
+                  <p:tgtEl>
+                    <p:sldTgt/>
+                  </p:tgtEl>
+                </p:cond>
+              </p:nextCondLst>
+            </p:seq>
+          </p:childTnLst>
+        </p:cTn>
+      </p:par>
+    </p:tnLst>
+  </p:timing>
 </p:sld>
 </file>
 
@@ -4081,6 +4249,209 @@
   <p:clrMapOvr>
     <a:masterClrMapping/>
   </p:clrMapOvr>
+  <mc:AlternateContent xmlns:mc="http://schemas.openxmlformats.org/markup-compatibility/2006">
+    <mc:Choice xmlns:p14="http://schemas.microsoft.com/office/powerpoint/2010/main" Requires="p14">
+      <p:transition spd="med" p14:dur="700">
+        <p:fade/>
+      </p:transition>
+    </mc:Choice>
+    <mc:Fallback>
+      <p:transition spd="med">
+        <p:fade/>
+      </p:transition>
+    </mc:Fallback>
+  </mc:AlternateContent>
+  <p:timing>
+    <p:tnLst>
+      <p:par>
+        <p:cTn id="1" dur="indefinite" restart="never" nodeType="tmRoot">
+          <p:childTnLst>
+            <p:seq concurrent="1" nextAc="seek">
+              <p:cTn id="2" dur="indefinite" nodeType="mainSeq">
+                <p:childTnLst>
+                  <p:par>
+                    <p:cTn id="3" fill="hold">
+                      <p:stCondLst>
+                        <p:cond delay="indefinite"/>
+                        <p:cond evt="onBegin" delay="0">
+                          <p:tn val="2"/>
+                        </p:cond>
+                      </p:stCondLst>
+                      <p:childTnLst>
+                        <p:par>
+                          <p:cTn id="4" fill="hold">
+                            <p:stCondLst>
+                              <p:cond delay="0"/>
+                            </p:stCondLst>
+                            <p:childTnLst>
+                              <p:par>
+                                <p:cTn id="5" presetID="10" presetClass="entr" presetSubtype="0" fill="hold" nodeType="afterEffect">
+                                  <p:stCondLst>
+                                    <p:cond delay="0"/>
+                                  </p:stCondLst>
+                                  <p:childTnLst>
+                                    <p:set>
+                                      <p:cBhvr>
+                                        <p:cTn id="6" dur="1" fill="hold">
+                                          <p:stCondLst>
+                                            <p:cond delay="0"/>
+                                          </p:stCondLst>
+                                        </p:cTn>
+                                        <p:tgtEl>
+                                          <p:spTgt spid="4"/>
+                                        </p:tgtEl>
+                                        <p:attrNameLst>
+                                          <p:attrName>style.visibility</p:attrName>
+                                        </p:attrNameLst>
+                                      </p:cBhvr>
+                                      <p:to>
+                                        <p:strVal val="visible"/>
+                                      </p:to>
+                                    </p:set>
+                                    <p:animEffect transition="in" filter="fade">
+                                      <p:cBhvr>
+                                        <p:cTn id="7" dur="500"/>
+                                        <p:tgtEl>
+                                          <p:spTgt spid="4"/>
+                                        </p:tgtEl>
+                                      </p:cBhvr>
+                                    </p:animEffect>
+                                  </p:childTnLst>
+                                </p:cTn>
+                              </p:par>
+                              <p:par>
+                                <p:cTn id="8" presetID="10" presetClass="entr" presetSubtype="0" fill="hold" nodeType="withEffect">
+                                  <p:stCondLst>
+                                    <p:cond delay="300"/>
+                                  </p:stCondLst>
+                                  <p:childTnLst>
+                                    <p:set>
+                                      <p:cBhvr>
+                                        <p:cTn id="9" dur="1" fill="hold">
+                                          <p:stCondLst>
+                                            <p:cond delay="0"/>
+                                          </p:stCondLst>
+                                        </p:cTn>
+                                        <p:tgtEl>
+                                          <p:spTgt spid="17"/>
+                                        </p:tgtEl>
+                                        <p:attrNameLst>
+                                          <p:attrName>style.visibility</p:attrName>
+                                        </p:attrNameLst>
+                                      </p:cBhvr>
+                                      <p:to>
+                                        <p:strVal val="visible"/>
+                                      </p:to>
+                                    </p:set>
+                                    <p:animEffect transition="in" filter="fade">
+                                      <p:cBhvr>
+                                        <p:cTn id="10" dur="500"/>
+                                        <p:tgtEl>
+                                          <p:spTgt spid="17"/>
+                                        </p:tgtEl>
+                                      </p:cBhvr>
+                                    </p:animEffect>
+                                  </p:childTnLst>
+                                </p:cTn>
+                              </p:par>
+                              <p:par>
+                                <p:cTn id="11" presetID="10" presetClass="entr" presetSubtype="0" fill="hold" nodeType="withEffect">
+                                  <p:stCondLst>
+                                    <p:cond delay="600"/>
+                                  </p:stCondLst>
+                                  <p:childTnLst>
+                                    <p:set>
+                                      <p:cBhvr>
+                                        <p:cTn id="12" dur="1" fill="hold">
+                                          <p:stCondLst>
+                                            <p:cond delay="0"/>
+                                          </p:stCondLst>
+                                        </p:cTn>
+                                        <p:tgtEl>
+                                          <p:spTgt spid="18"/>
+                                        </p:tgtEl>
+                                        <p:attrNameLst>
+                                          <p:attrName>style.visibility</p:attrName>
+                                        </p:attrNameLst>
+                                      </p:cBhvr>
+                                      <p:to>
+                                        <p:strVal val="visible"/>
+                                      </p:to>
+                                    </p:set>
+                                    <p:animEffect transition="in" filter="fade">
+                                      <p:cBhvr>
+                                        <p:cTn id="13" dur="500"/>
+                                        <p:tgtEl>
+                                          <p:spTgt spid="18"/>
+                                        </p:tgtEl>
+                                      </p:cBhvr>
+                                    </p:animEffect>
+                                  </p:childTnLst>
+                                </p:cTn>
+                              </p:par>
+                              <p:par>
+                                <p:cTn id="14" presetID="10" presetClass="entr" presetSubtype="0" fill="hold" nodeType="withEffect">
+                                  <p:stCondLst>
+                                    <p:cond delay="900"/>
+                                  </p:stCondLst>
+                                  <p:childTnLst>
+                                    <p:set>
+                                      <p:cBhvr>
+                                        <p:cTn id="15" dur="1" fill="hold">
+                                          <p:stCondLst>
+                                            <p:cond delay="0"/>
+                                          </p:stCondLst>
+                                        </p:cTn>
+                                        <p:tgtEl>
+                                          <p:spTgt spid="19"/>
+                                        </p:tgtEl>
+                                        <p:attrNameLst>
+                                          <p:attrName>style.visibility</p:attrName>
+                                        </p:attrNameLst>
+                                      </p:cBhvr>
+                                      <p:to>
+                                        <p:strVal val="visible"/>
+                                      </p:to>
+                                    </p:set>
+                                    <p:animEffect transition="in" filter="fade">
+                                      <p:cBhvr>
+                                        <p:cTn id="16" dur="500"/>
+                                        <p:tgtEl>
+                                          <p:spTgt spid="19"/>
+                                        </p:tgtEl>
+                                      </p:cBhvr>
+                                    </p:animEffect>
+                                  </p:childTnLst>
+                                </p:cTn>
+                              </p:par>
+                            </p:childTnLst>
+                          </p:cTn>
+                        </p:par>
+                      </p:childTnLst>
+                    </p:cTn>
+                  </p:par>
+                </p:childTnLst>
+              </p:cTn>
+              <p:prevCondLst>
+                <p:cond evt="onPrev" delay="0">
+                  <p:tgtEl>
+                    <p:sldTgt/>
+                  </p:tgtEl>
+                </p:cond>
+              </p:prevCondLst>
+              <p:nextCondLst>
+                <p:cond evt="onNext" delay="0">
+                  <p:tgtEl>
+                    <p:sldTgt/>
+                  </p:tgtEl>
+                </p:cond>
+              </p:nextCondLst>
+            </p:seq>
+          </p:childTnLst>
+        </p:cTn>
+      </p:par>
+    </p:tnLst>
+  </p:timing>
 </p:sld>
 </file>
 
@@ -5110,6 +5481,174 @@
   <p:clrMapOvr>
     <a:masterClrMapping/>
   </p:clrMapOvr>
+  <mc:AlternateContent xmlns:mc="http://schemas.openxmlformats.org/markup-compatibility/2006">
+    <mc:Choice xmlns:p14="http://schemas.microsoft.com/office/powerpoint/2010/main" Requires="p14">
+      <p:transition spd="med" p14:dur="700">
+        <p:fade/>
+      </p:transition>
+    </mc:Choice>
+    <mc:Fallback>
+      <p:transition spd="med">
+        <p:fade/>
+      </p:transition>
+    </mc:Fallback>
+  </mc:AlternateContent>
+  <p:timing>
+    <p:tnLst>
+      <p:par>
+        <p:cTn id="1" dur="indefinite" restart="never" nodeType="tmRoot">
+          <p:childTnLst>
+            <p:seq concurrent="1" nextAc="seek">
+              <p:cTn id="2" dur="indefinite" nodeType="mainSeq">
+                <p:childTnLst>
+                  <p:par>
+                    <p:cTn id="3" fill="hold">
+                      <p:stCondLst>
+                        <p:cond delay="indefinite"/>
+                        <p:cond evt="onBegin" delay="0">
+                          <p:tn val="2"/>
+                        </p:cond>
+                      </p:stCondLst>
+                      <p:childTnLst>
+                        <p:par>
+                          <p:cTn id="4" fill="hold">
+                            <p:stCondLst>
+                              <p:cond delay="0"/>
+                            </p:stCondLst>
+                            <p:childTnLst>
+                              <p:par>
+                                <p:cTn id="5" presetID="10" presetClass="entr" presetSubtype="0" fill="hold" nodeType="afterEffect">
+                                  <p:stCondLst>
+                                    <p:cond delay="0"/>
+                                  </p:stCondLst>
+                                  <p:childTnLst>
+                                    <p:set>
+                                      <p:cBhvr>
+                                        <p:cTn id="6" dur="1" fill="hold">
+                                          <p:stCondLst>
+                                            <p:cond delay="0"/>
+                                          </p:stCondLst>
+                                        </p:cTn>
+                                        <p:tgtEl>
+                                          <p:spTgt spid="4"/>
+                                        </p:tgtEl>
+                                        <p:attrNameLst>
+                                          <p:attrName>style.visibility</p:attrName>
+                                        </p:attrNameLst>
+                                      </p:cBhvr>
+                                      <p:to>
+                                        <p:strVal val="visible"/>
+                                      </p:to>
+                                    </p:set>
+                                    <p:animEffect transition="in" filter="fade">
+                                      <p:cBhvr>
+                                        <p:cTn id="7" dur="500"/>
+                                        <p:tgtEl>
+                                          <p:spTgt spid="4"/>
+                                        </p:tgtEl>
+                                      </p:cBhvr>
+                                    </p:animEffect>
+                                  </p:childTnLst>
+                                </p:cTn>
+                              </p:par>
+                              <p:par>
+                                <p:cTn id="8" presetID="10" presetClass="entr" presetSubtype="0" fill="hold" nodeType="withEffect">
+                                  <p:stCondLst>
+                                    <p:cond delay="300"/>
+                                  </p:stCondLst>
+                                  <p:childTnLst>
+                                    <p:set>
+                                      <p:cBhvr>
+                                        <p:cTn id="9" dur="1" fill="hold">
+                                          <p:stCondLst>
+                                            <p:cond delay="0"/>
+                                          </p:stCondLst>
+                                        </p:cTn>
+                                        <p:tgtEl>
+                                          <p:spTgt spid="29"/>
+                                        </p:tgtEl>
+                                        <p:attrNameLst>
+                                          <p:attrName>style.visibility</p:attrName>
+                                        </p:attrNameLst>
+                                      </p:cBhvr>
+                                      <p:to>
+                                        <p:strVal val="visible"/>
+                                      </p:to>
+                                    </p:set>
+                                    <p:animEffect transition="in" filter="fade">
+                                      <p:cBhvr>
+                                        <p:cTn id="10" dur="500"/>
+                                        <p:tgtEl>
+                                          <p:spTgt spid="29"/>
+                                        </p:tgtEl>
+                                      </p:cBhvr>
+                                    </p:animEffect>
+                                  </p:childTnLst>
+                                </p:cTn>
+                              </p:par>
+                              <p:par>
+                                <p:cTn id="11" presetID="10" presetClass="entr" presetSubtype="0" fill="hold" nodeType="withEffect">
+                                  <p:stCondLst>
+                                    <p:cond delay="600"/>
+                                  </p:stCondLst>
+                                  <p:childTnLst>
+                                    <p:set>
+                                      <p:cBhvr>
+                                        <p:cTn id="12" dur="1" fill="hold">
+                                          <p:stCondLst>
+                                            <p:cond delay="0"/>
+                                          </p:stCondLst>
+                                        </p:cTn>
+                                        <p:tgtEl>
+                                          <p:spTgt spid="30"/>
+                                        </p:tgtEl>
+                                        <p:attrNameLst>
+                                          <p:attrName>style.visibility</p:attrName>
+                                        </p:attrNameLst>
+                                      </p:cBhvr>
+                                      <p:to>
+                                        <p:strVal val="visible"/>
+                                      </p:to>
+                                    </p:set>
+                                    <p:animEffect transition="in" filter="fade">
+                                      <p:cBhvr>
+                                        <p:cTn id="13" dur="500"/>
+                                        <p:tgtEl>
+                                          <p:spTgt spid="30"/>
+                                        </p:tgtEl>
+                                      </p:cBhvr>
+                                    </p:animEffect>
+                                  </p:childTnLst>
+                                </p:cTn>
+                              </p:par>
+                            </p:childTnLst>
+                          </p:cTn>
+                        </p:par>
+                      </p:childTnLst>
+                    </p:cTn>
+                  </p:par>
+                </p:childTnLst>
+              </p:cTn>
+              <p:prevCondLst>
+                <p:cond evt="onPrev" delay="0">
+                  <p:tgtEl>
+                    <p:sldTgt/>
+                  </p:tgtEl>
+                </p:cond>
+              </p:prevCondLst>
+              <p:nextCondLst>
+                <p:cond evt="onNext" delay="0">
+                  <p:tgtEl>
+                    <p:sldTgt/>
+                  </p:tgtEl>
+                </p:cond>
+              </p:nextCondLst>
+            </p:seq>
+          </p:childTnLst>
+        </p:cTn>
+      </p:par>
+    </p:tnLst>
+  </p:timing>
 </p:sld>
 </file>
 
@@ -6727,6 +7266,174 @@
   <p:clrMapOvr>
     <a:masterClrMapping/>
   </p:clrMapOvr>
+  <mc:AlternateContent xmlns:mc="http://schemas.openxmlformats.org/markup-compatibility/2006">
+    <mc:Choice xmlns:p14="http://schemas.microsoft.com/office/powerpoint/2010/main" Requires="p14">
+      <p:transition spd="med" p14:dur="700">
+        <p:fade/>
+      </p:transition>
+    </mc:Choice>
+    <mc:Fallback>
+      <p:transition spd="med">
+        <p:fade/>
+      </p:transition>
+    </mc:Fallback>
+  </mc:AlternateContent>
+  <p:timing>
+    <p:tnLst>
+      <p:par>
+        <p:cTn id="1" dur="indefinite" restart="never" nodeType="tmRoot">
+          <p:childTnLst>
+            <p:seq concurrent="1" nextAc="seek">
+              <p:cTn id="2" dur="indefinite" nodeType="mainSeq">
+                <p:childTnLst>
+                  <p:par>
+                    <p:cTn id="3" fill="hold">
+                      <p:stCondLst>
+                        <p:cond delay="indefinite"/>
+                        <p:cond evt="onBegin" delay="0">
+                          <p:tn val="2"/>
+                        </p:cond>
+                      </p:stCondLst>
+                      <p:childTnLst>
+                        <p:par>
+                          <p:cTn id="4" fill="hold">
+                            <p:stCondLst>
+                              <p:cond delay="0"/>
+                            </p:stCondLst>
+                            <p:childTnLst>
+                              <p:par>
+                                <p:cTn id="5" presetID="10" presetClass="entr" presetSubtype="0" fill="hold" nodeType="afterEffect">
+                                  <p:stCondLst>
+                                    <p:cond delay="0"/>
+                                  </p:stCondLst>
+                                  <p:childTnLst>
+                                    <p:set>
+                                      <p:cBhvr>
+                                        <p:cTn id="6" dur="1" fill="hold">
+                                          <p:stCondLst>
+                                            <p:cond delay="0"/>
+                                          </p:stCondLst>
+                                        </p:cTn>
+                                        <p:tgtEl>
+                                          <p:spTgt spid="4"/>
+                                        </p:tgtEl>
+                                        <p:attrNameLst>
+                                          <p:attrName>style.visibility</p:attrName>
+                                        </p:attrNameLst>
+                                      </p:cBhvr>
+                                      <p:to>
+                                        <p:strVal val="visible"/>
+                                      </p:to>
+                                    </p:set>
+                                    <p:animEffect transition="in" filter="fade">
+                                      <p:cBhvr>
+                                        <p:cTn id="7" dur="500"/>
+                                        <p:tgtEl>
+                                          <p:spTgt spid="4"/>
+                                        </p:tgtEl>
+                                      </p:cBhvr>
+                                    </p:animEffect>
+                                  </p:childTnLst>
+                                </p:cTn>
+                              </p:par>
+                              <p:par>
+                                <p:cTn id="8" presetID="10" presetClass="entr" presetSubtype="0" fill="hold" nodeType="withEffect">
+                                  <p:stCondLst>
+                                    <p:cond delay="300"/>
+                                  </p:stCondLst>
+                                  <p:childTnLst>
+                                    <p:set>
+                                      <p:cBhvr>
+                                        <p:cTn id="9" dur="1" fill="hold">
+                                          <p:stCondLst>
+                                            <p:cond delay="0"/>
+                                          </p:stCondLst>
+                                        </p:cTn>
+                                        <p:tgtEl>
+                                          <p:spTgt spid="51"/>
+                                        </p:tgtEl>
+                                        <p:attrNameLst>
+                                          <p:attrName>style.visibility</p:attrName>
+                                        </p:attrNameLst>
+                                      </p:cBhvr>
+                                      <p:to>
+                                        <p:strVal val="visible"/>
+                                      </p:to>
+                                    </p:set>
+                                    <p:animEffect transition="in" filter="fade">
+                                      <p:cBhvr>
+                                        <p:cTn id="10" dur="500"/>
+                                        <p:tgtEl>
+                                          <p:spTgt spid="51"/>
+                                        </p:tgtEl>
+                                      </p:cBhvr>
+                                    </p:animEffect>
+                                  </p:childTnLst>
+                                </p:cTn>
+                              </p:par>
+                              <p:par>
+                                <p:cTn id="11" presetID="10" presetClass="entr" presetSubtype="0" fill="hold" nodeType="withEffect">
+                                  <p:stCondLst>
+                                    <p:cond delay="600"/>
+                                  </p:stCondLst>
+                                  <p:childTnLst>
+                                    <p:set>
+                                      <p:cBhvr>
+                                        <p:cTn id="12" dur="1" fill="hold">
+                                          <p:stCondLst>
+                                            <p:cond delay="0"/>
+                                          </p:stCondLst>
+                                        </p:cTn>
+                                        <p:tgtEl>
+                                          <p:spTgt spid="52"/>
+                                        </p:tgtEl>
+                                        <p:attrNameLst>
+                                          <p:attrName>style.visibility</p:attrName>
+                                        </p:attrNameLst>
+                                      </p:cBhvr>
+                                      <p:to>
+                                        <p:strVal val="visible"/>
+                                      </p:to>
+                                    </p:set>
+                                    <p:animEffect transition="in" filter="fade">
+                                      <p:cBhvr>
+                                        <p:cTn id="13" dur="500"/>
+                                        <p:tgtEl>
+                                          <p:spTgt spid="52"/>
+                                        </p:tgtEl>
+                                      </p:cBhvr>
+                                    </p:animEffect>
+                                  </p:childTnLst>
+                                </p:cTn>
+                              </p:par>
+                            </p:childTnLst>
+                          </p:cTn>
+                        </p:par>
+                      </p:childTnLst>
+                    </p:cTn>
+                  </p:par>
+                </p:childTnLst>
+              </p:cTn>
+              <p:prevCondLst>
+                <p:cond evt="onPrev" delay="0">
+                  <p:tgtEl>
+                    <p:sldTgt/>
+                  </p:tgtEl>
+                </p:cond>
+              </p:prevCondLst>
+              <p:nextCondLst>
+                <p:cond evt="onNext" delay="0">
+                  <p:tgtEl>
+                    <p:sldTgt/>
+                  </p:tgtEl>
+                </p:cond>
+              </p:nextCondLst>
+            </p:seq>
+          </p:childTnLst>
+        </p:cTn>
+      </p:par>
+    </p:tnLst>
+  </p:timing>
 </p:sld>
 </file>
 
@@ -9315,6 +10022,174 @@
   <p:clrMapOvr>
     <a:masterClrMapping/>
   </p:clrMapOvr>
+  <mc:AlternateContent xmlns:mc="http://schemas.openxmlformats.org/markup-compatibility/2006">
+    <mc:Choice xmlns:p14="http://schemas.microsoft.com/office/powerpoint/2010/main" Requires="p14">
+      <p:transition spd="med" p14:dur="700">
+        <p:fade/>
+      </p:transition>
+    </mc:Choice>
+    <mc:Fallback>
+      <p:transition spd="med">
+        <p:fade/>
+      </p:transition>
+    </mc:Fallback>
+  </mc:AlternateContent>
+  <p:timing>
+    <p:tnLst>
+      <p:par>
+        <p:cTn id="1" dur="indefinite" restart="never" nodeType="tmRoot">
+          <p:childTnLst>
+            <p:seq concurrent="1" nextAc="seek">
+              <p:cTn id="2" dur="indefinite" nodeType="mainSeq">
+                <p:childTnLst>
+                  <p:par>
+                    <p:cTn id="3" fill="hold">
+                      <p:stCondLst>
+                        <p:cond delay="indefinite"/>
+                        <p:cond evt="onBegin" delay="0">
+                          <p:tn val="2"/>
+                        </p:cond>
+                      </p:stCondLst>
+                      <p:childTnLst>
+                        <p:par>
+                          <p:cTn id="4" fill="hold">
+                            <p:stCondLst>
+                              <p:cond delay="0"/>
+                            </p:stCondLst>
+                            <p:childTnLst>
+                              <p:par>
+                                <p:cTn id="5" presetID="10" presetClass="entr" presetSubtype="0" fill="hold" nodeType="afterEffect">
+                                  <p:stCondLst>
+                                    <p:cond delay="0"/>
+                                  </p:stCondLst>
+                                  <p:childTnLst>
+                                    <p:set>
+                                      <p:cBhvr>
+                                        <p:cTn id="6" dur="1" fill="hold">
+                                          <p:stCondLst>
+                                            <p:cond delay="0"/>
+                                          </p:stCondLst>
+                                        </p:cTn>
+                                        <p:tgtEl>
+                                          <p:spTgt spid="4"/>
+                                        </p:tgtEl>
+                                        <p:attrNameLst>
+                                          <p:attrName>style.visibility</p:attrName>
+                                        </p:attrNameLst>
+                                      </p:cBhvr>
+                                      <p:to>
+                                        <p:strVal val="visible"/>
+                                      </p:to>
+                                    </p:set>
+                                    <p:animEffect transition="in" filter="fade">
+                                      <p:cBhvr>
+                                        <p:cTn id="7" dur="500"/>
+                                        <p:tgtEl>
+                                          <p:spTgt spid="4"/>
+                                        </p:tgtEl>
+                                      </p:cBhvr>
+                                    </p:animEffect>
+                                  </p:childTnLst>
+                                </p:cTn>
+                              </p:par>
+                              <p:par>
+                                <p:cTn id="8" presetID="10" presetClass="entr" presetSubtype="0" fill="hold" nodeType="withEffect">
+                                  <p:stCondLst>
+                                    <p:cond delay="300"/>
+                                  </p:stCondLst>
+                                  <p:childTnLst>
+                                    <p:set>
+                                      <p:cBhvr>
+                                        <p:cTn id="9" dur="1" fill="hold">
+                                          <p:stCondLst>
+                                            <p:cond delay="0"/>
+                                          </p:stCondLst>
+                                        </p:cTn>
+                                        <p:tgtEl>
+                                          <p:spTgt spid="94"/>
+                                        </p:tgtEl>
+                                        <p:attrNameLst>
+                                          <p:attrName>style.visibility</p:attrName>
+                                        </p:attrNameLst>
+                                      </p:cBhvr>
+                                      <p:to>
+                                        <p:strVal val="visible"/>
+                                      </p:to>
+                                    </p:set>
+                                    <p:animEffect transition="in" filter="fade">
+                                      <p:cBhvr>
+                                        <p:cTn id="10" dur="500"/>
+                                        <p:tgtEl>
+                                          <p:spTgt spid="94"/>
+                                        </p:tgtEl>
+                                      </p:cBhvr>
+                                    </p:animEffect>
+                                  </p:childTnLst>
+                                </p:cTn>
+                              </p:par>
+                              <p:par>
+                                <p:cTn id="11" presetID="10" presetClass="entr" presetSubtype="0" fill="hold" nodeType="withEffect">
+                                  <p:stCondLst>
+                                    <p:cond delay="600"/>
+                                  </p:stCondLst>
+                                  <p:childTnLst>
+                                    <p:set>
+                                      <p:cBhvr>
+                                        <p:cTn id="12" dur="1" fill="hold">
+                                          <p:stCondLst>
+                                            <p:cond delay="0"/>
+                                          </p:stCondLst>
+                                        </p:cTn>
+                                        <p:tgtEl>
+                                          <p:spTgt spid="95"/>
+                                        </p:tgtEl>
+                                        <p:attrNameLst>
+                                          <p:attrName>style.visibility</p:attrName>
+                                        </p:attrNameLst>
+                                      </p:cBhvr>
+                                      <p:to>
+                                        <p:strVal val="visible"/>
+                                      </p:to>
+                                    </p:set>
+                                    <p:animEffect transition="in" filter="fade">
+                                      <p:cBhvr>
+                                        <p:cTn id="13" dur="500"/>
+                                        <p:tgtEl>
+                                          <p:spTgt spid="95"/>
+                                        </p:tgtEl>
+                                      </p:cBhvr>
+                                    </p:animEffect>
+                                  </p:childTnLst>
+                                </p:cTn>
+                              </p:par>
+                            </p:childTnLst>
+                          </p:cTn>
+                        </p:par>
+                      </p:childTnLst>
+                    </p:cTn>
+                  </p:par>
+                </p:childTnLst>
+              </p:cTn>
+              <p:prevCondLst>
+                <p:cond evt="onPrev" delay="0">
+                  <p:tgtEl>
+                    <p:sldTgt/>
+                  </p:tgtEl>
+                </p:cond>
+              </p:prevCondLst>
+              <p:nextCondLst>
+                <p:cond evt="onNext" delay="0">
+                  <p:tgtEl>
+                    <p:sldTgt/>
+                  </p:tgtEl>
+                </p:cond>
+              </p:nextCondLst>
+            </p:seq>
+          </p:childTnLst>
+        </p:cTn>
+      </p:par>
+    </p:tnLst>
+  </p:timing>
 </p:sld>
 </file>
 
@@ -10235,6 +11110,209 @@
   <p:clrMapOvr>
     <a:masterClrMapping/>
   </p:clrMapOvr>
+  <mc:AlternateContent xmlns:mc="http://schemas.openxmlformats.org/markup-compatibility/2006">
+    <mc:Choice xmlns:p14="http://schemas.microsoft.com/office/powerpoint/2010/main" Requires="p14">
+      <p:transition spd="med" p14:dur="700">
+        <p:fade/>
+      </p:transition>
+    </mc:Choice>
+    <mc:Fallback>
+      <p:transition spd="med">
+        <p:fade/>
+      </p:transition>
+    </mc:Fallback>
+  </mc:AlternateContent>
+  <p:timing>
+    <p:tnLst>
+      <p:par>
+        <p:cTn id="1" dur="indefinite" restart="never" nodeType="tmRoot">
+          <p:childTnLst>
+            <p:seq concurrent="1" nextAc="seek">
+              <p:cTn id="2" dur="indefinite" nodeType="mainSeq">
+                <p:childTnLst>
+                  <p:par>
+                    <p:cTn id="3" fill="hold">
+                      <p:stCondLst>
+                        <p:cond delay="indefinite"/>
+                        <p:cond evt="onBegin" delay="0">
+                          <p:tn val="2"/>
+                        </p:cond>
+                      </p:stCondLst>
+                      <p:childTnLst>
+                        <p:par>
+                          <p:cTn id="4" fill="hold">
+                            <p:stCondLst>
+                              <p:cond delay="0"/>
+                            </p:stCondLst>
+                            <p:childTnLst>
+                              <p:par>
+                                <p:cTn id="5" presetID="10" presetClass="entr" presetSubtype="0" fill="hold" nodeType="afterEffect">
+                                  <p:stCondLst>
+                                    <p:cond delay="0"/>
+                                  </p:stCondLst>
+                                  <p:childTnLst>
+                                    <p:set>
+                                      <p:cBhvr>
+                                        <p:cTn id="6" dur="1" fill="hold">
+                                          <p:stCondLst>
+                                            <p:cond delay="0"/>
+                                          </p:stCondLst>
+                                        </p:cTn>
+                                        <p:tgtEl>
+                                          <p:spTgt spid="4"/>
+                                        </p:tgtEl>
+                                        <p:attrNameLst>
+                                          <p:attrName>style.visibility</p:attrName>
+                                        </p:attrNameLst>
+                                      </p:cBhvr>
+                                      <p:to>
+                                        <p:strVal val="visible"/>
+                                      </p:to>
+                                    </p:set>
+                                    <p:animEffect transition="in" filter="fade">
+                                      <p:cBhvr>
+                                        <p:cTn id="7" dur="500"/>
+                                        <p:tgtEl>
+                                          <p:spTgt spid="4"/>
+                                        </p:tgtEl>
+                                      </p:cBhvr>
+                                    </p:animEffect>
+                                  </p:childTnLst>
+                                </p:cTn>
+                              </p:par>
+                              <p:par>
+                                <p:cTn id="8" presetID="10" presetClass="entr" presetSubtype="0" fill="hold" nodeType="withEffect">
+                                  <p:stCondLst>
+                                    <p:cond delay="300"/>
+                                  </p:stCondLst>
+                                  <p:childTnLst>
+                                    <p:set>
+                                      <p:cBhvr>
+                                        <p:cTn id="9" dur="1" fill="hold">
+                                          <p:stCondLst>
+                                            <p:cond delay="0"/>
+                                          </p:stCondLst>
+                                        </p:cTn>
+                                        <p:tgtEl>
+                                          <p:spTgt spid="21"/>
+                                        </p:tgtEl>
+                                        <p:attrNameLst>
+                                          <p:attrName>style.visibility</p:attrName>
+                                        </p:attrNameLst>
+                                      </p:cBhvr>
+                                      <p:to>
+                                        <p:strVal val="visible"/>
+                                      </p:to>
+                                    </p:set>
+                                    <p:animEffect transition="in" filter="fade">
+                                      <p:cBhvr>
+                                        <p:cTn id="10" dur="500"/>
+                                        <p:tgtEl>
+                                          <p:spTgt spid="21"/>
+                                        </p:tgtEl>
+                                      </p:cBhvr>
+                                    </p:animEffect>
+                                  </p:childTnLst>
+                                </p:cTn>
+                              </p:par>
+                              <p:par>
+                                <p:cTn id="11" presetID="10" presetClass="entr" presetSubtype="0" fill="hold" nodeType="withEffect">
+                                  <p:stCondLst>
+                                    <p:cond delay="600"/>
+                                  </p:stCondLst>
+                                  <p:childTnLst>
+                                    <p:set>
+                                      <p:cBhvr>
+                                        <p:cTn id="12" dur="1" fill="hold">
+                                          <p:stCondLst>
+                                            <p:cond delay="0"/>
+                                          </p:stCondLst>
+                                        </p:cTn>
+                                        <p:tgtEl>
+                                          <p:spTgt spid="22"/>
+                                        </p:tgtEl>
+                                        <p:attrNameLst>
+                                          <p:attrName>style.visibility</p:attrName>
+                                        </p:attrNameLst>
+                                      </p:cBhvr>
+                                      <p:to>
+                                        <p:strVal val="visible"/>
+                                      </p:to>
+                                    </p:set>
+                                    <p:animEffect transition="in" filter="fade">
+                                      <p:cBhvr>
+                                        <p:cTn id="13" dur="500"/>
+                                        <p:tgtEl>
+                                          <p:spTgt spid="22"/>
+                                        </p:tgtEl>
+                                      </p:cBhvr>
+                                    </p:animEffect>
+                                  </p:childTnLst>
+                                </p:cTn>
+                              </p:par>
+                              <p:par>
+                                <p:cTn id="14" presetID="10" presetClass="entr" presetSubtype="0" fill="hold" nodeType="withEffect">
+                                  <p:stCondLst>
+                                    <p:cond delay="900"/>
+                                  </p:stCondLst>
+                                  <p:childTnLst>
+                                    <p:set>
+                                      <p:cBhvr>
+                                        <p:cTn id="15" dur="1" fill="hold">
+                                          <p:stCondLst>
+                                            <p:cond delay="0"/>
+                                          </p:stCondLst>
+                                        </p:cTn>
+                                        <p:tgtEl>
+                                          <p:spTgt spid="23"/>
+                                        </p:tgtEl>
+                                        <p:attrNameLst>
+                                          <p:attrName>style.visibility</p:attrName>
+                                        </p:attrNameLst>
+                                      </p:cBhvr>
+                                      <p:to>
+                                        <p:strVal val="visible"/>
+                                      </p:to>
+                                    </p:set>
+                                    <p:animEffect transition="in" filter="fade">
+                                      <p:cBhvr>
+                                        <p:cTn id="16" dur="500"/>
+                                        <p:tgtEl>
+                                          <p:spTgt spid="23"/>
+                                        </p:tgtEl>
+                                      </p:cBhvr>
+                                    </p:animEffect>
+                                  </p:childTnLst>
+                                </p:cTn>
+                              </p:par>
+                            </p:childTnLst>
+                          </p:cTn>
+                        </p:par>
+                      </p:childTnLst>
+                    </p:cTn>
+                  </p:par>
+                </p:childTnLst>
+              </p:cTn>
+              <p:prevCondLst>
+                <p:cond evt="onPrev" delay="0">
+                  <p:tgtEl>
+                    <p:sldTgt/>
+                  </p:tgtEl>
+                </p:cond>
+              </p:prevCondLst>
+              <p:nextCondLst>
+                <p:cond evt="onNext" delay="0">
+                  <p:tgtEl>
+                    <p:sldTgt/>
+                  </p:tgtEl>
+                </p:cond>
+              </p:nextCondLst>
+            </p:seq>
+          </p:childTnLst>
+        </p:cTn>
+      </p:par>
+    </p:tnLst>
+  </p:timing>
 </p:sld>
 </file>
 
@@ -12328,6 +13406,244 @@
   <p:clrMapOvr>
     <a:masterClrMapping/>
   </p:clrMapOvr>
+  <mc:AlternateContent xmlns:mc="http://schemas.openxmlformats.org/markup-compatibility/2006">
+    <mc:Choice xmlns:p14="http://schemas.microsoft.com/office/powerpoint/2010/main" Requires="p14">
+      <p:transition spd="med" p14:dur="700">
+        <p:fade/>
+      </p:transition>
+    </mc:Choice>
+    <mc:Fallback>
+      <p:transition spd="med">
+        <p:fade/>
+      </p:transition>
+    </mc:Fallback>
+  </mc:AlternateContent>
+  <p:timing>
+    <p:tnLst>
+      <p:par>
+        <p:cTn id="1" dur="indefinite" restart="never" nodeType="tmRoot">
+          <p:childTnLst>
+            <p:seq concurrent="1" nextAc="seek">
+              <p:cTn id="2" dur="indefinite" nodeType="mainSeq">
+                <p:childTnLst>
+                  <p:par>
+                    <p:cTn id="3" fill="hold">
+                      <p:stCondLst>
+                        <p:cond delay="indefinite"/>
+                        <p:cond evt="onBegin" delay="0">
+                          <p:tn val="2"/>
+                        </p:cond>
+                      </p:stCondLst>
+                      <p:childTnLst>
+                        <p:par>
+                          <p:cTn id="4" fill="hold">
+                            <p:stCondLst>
+                              <p:cond delay="0"/>
+                            </p:stCondLst>
+                            <p:childTnLst>
+                              <p:par>
+                                <p:cTn id="5" presetID="10" presetClass="entr" presetSubtype="0" fill="hold" nodeType="afterEffect">
+                                  <p:stCondLst>
+                                    <p:cond delay="0"/>
+                                  </p:stCondLst>
+                                  <p:childTnLst>
+                                    <p:set>
+                                      <p:cBhvr>
+                                        <p:cTn id="6" dur="1" fill="hold">
+                                          <p:stCondLst>
+                                            <p:cond delay="0"/>
+                                          </p:stCondLst>
+                                        </p:cTn>
+                                        <p:tgtEl>
+                                          <p:spTgt spid="4"/>
+                                        </p:tgtEl>
+                                        <p:attrNameLst>
+                                          <p:attrName>style.visibility</p:attrName>
+                                        </p:attrNameLst>
+                                      </p:cBhvr>
+                                      <p:to>
+                                        <p:strVal val="visible"/>
+                                      </p:to>
+                                    </p:set>
+                                    <p:animEffect transition="in" filter="fade">
+                                      <p:cBhvr>
+                                        <p:cTn id="7" dur="500"/>
+                                        <p:tgtEl>
+                                          <p:spTgt spid="4"/>
+                                        </p:tgtEl>
+                                      </p:cBhvr>
+                                    </p:animEffect>
+                                  </p:childTnLst>
+                                </p:cTn>
+                              </p:par>
+                              <p:par>
+                                <p:cTn id="8" presetID="10" presetClass="entr" presetSubtype="0" fill="hold" nodeType="withEffect">
+                                  <p:stCondLst>
+                                    <p:cond delay="300"/>
+                                  </p:stCondLst>
+                                  <p:childTnLst>
+                                    <p:set>
+                                      <p:cBhvr>
+                                        <p:cTn id="9" dur="1" fill="hold">
+                                          <p:stCondLst>
+                                            <p:cond delay="0"/>
+                                          </p:stCondLst>
+                                        </p:cTn>
+                                        <p:tgtEl>
+                                          <p:spTgt spid="17"/>
+                                        </p:tgtEl>
+                                        <p:attrNameLst>
+                                          <p:attrName>style.visibility</p:attrName>
+                                        </p:attrNameLst>
+                                      </p:cBhvr>
+                                      <p:to>
+                                        <p:strVal val="visible"/>
+                                      </p:to>
+                                    </p:set>
+                                    <p:animEffect transition="in" filter="fade">
+                                      <p:cBhvr>
+                                        <p:cTn id="10" dur="500"/>
+                                        <p:tgtEl>
+                                          <p:spTgt spid="17"/>
+                                        </p:tgtEl>
+                                      </p:cBhvr>
+                                    </p:animEffect>
+                                  </p:childTnLst>
+                                </p:cTn>
+                              </p:par>
+                              <p:par>
+                                <p:cTn id="11" presetID="10" presetClass="entr" presetSubtype="0" fill="hold" nodeType="withEffect">
+                                  <p:stCondLst>
+                                    <p:cond delay="600"/>
+                                  </p:stCondLst>
+                                  <p:childTnLst>
+                                    <p:set>
+                                      <p:cBhvr>
+                                        <p:cTn id="12" dur="1" fill="hold">
+                                          <p:stCondLst>
+                                            <p:cond delay="0"/>
+                                          </p:stCondLst>
+                                        </p:cTn>
+                                        <p:tgtEl>
+                                          <p:spTgt spid="18"/>
+                                        </p:tgtEl>
+                                        <p:attrNameLst>
+                                          <p:attrName>style.visibility</p:attrName>
+                                        </p:attrNameLst>
+                                      </p:cBhvr>
+                                      <p:to>
+                                        <p:strVal val="visible"/>
+                                      </p:to>
+                                    </p:set>
+                                    <p:animEffect transition="in" filter="fade">
+                                      <p:cBhvr>
+                                        <p:cTn id="13" dur="500"/>
+                                        <p:tgtEl>
+                                          <p:spTgt spid="18"/>
+                                        </p:tgtEl>
+                                      </p:cBhvr>
+                                    </p:animEffect>
+                                  </p:childTnLst>
+                                </p:cTn>
+                              </p:par>
+                              <p:par>
+                                <p:cTn id="14" presetID="10" presetClass="entr" presetSubtype="0" fill="hold" nodeType="withEffect">
+                                  <p:stCondLst>
+                                    <p:cond delay="900"/>
+                                  </p:stCondLst>
+                                  <p:childTnLst>
+                                    <p:set>
+                                      <p:cBhvr>
+                                        <p:cTn id="15" dur="1" fill="hold">
+                                          <p:stCondLst>
+                                            <p:cond delay="0"/>
+                                          </p:stCondLst>
+                                        </p:cTn>
+                                        <p:tgtEl>
+                                          <p:spTgt spid="19"/>
+                                        </p:tgtEl>
+                                        <p:attrNameLst>
+                                          <p:attrName>style.visibility</p:attrName>
+                                        </p:attrNameLst>
+                                      </p:cBhvr>
+                                      <p:to>
+                                        <p:strVal val="visible"/>
+                                      </p:to>
+                                    </p:set>
+                                    <p:animEffect transition="in" filter="fade">
+                                      <p:cBhvr>
+                                        <p:cTn id="16" dur="500"/>
+                                        <p:tgtEl>
+                                          <p:spTgt spid="19"/>
+                                        </p:tgtEl>
+                                      </p:cBhvr>
+                                    </p:animEffect>
+                                  </p:childTnLst>
+                                </p:cTn>
+                              </p:par>
+                              <p:par>
+                                <p:cTn id="17" presetID="10" presetClass="entr" presetSubtype="0" fill="hold" nodeType="withEffect">
+                                  <p:stCondLst>
+                                    <p:cond delay="1200"/>
+                                  </p:stCondLst>
+                                  <p:childTnLst>
+                                    <p:set>
+                                      <p:cBhvr>
+                                        <p:cTn id="18" dur="1" fill="hold">
+                                          <p:stCondLst>
+                                            <p:cond delay="0"/>
+                                          </p:stCondLst>
+                                        </p:cTn>
+                                        <p:tgtEl>
+                                          <p:spTgt spid="20"/>
+                                        </p:tgtEl>
+                                        <p:attrNameLst>
+                                          <p:attrName>style.visibility</p:attrName>
+                                        </p:attrNameLst>
+                                      </p:cBhvr>
+                                      <p:to>
+                                        <p:strVal val="visible"/>
+                                      </p:to>
+                                    </p:set>
+                                    <p:animEffect transition="in" filter="fade">
+                                      <p:cBhvr>
+                                        <p:cTn id="19" dur="500"/>
+                                        <p:tgtEl>
+                                          <p:spTgt spid="20"/>
+                                        </p:tgtEl>
+                                      </p:cBhvr>
+                                    </p:animEffect>
+                                  </p:childTnLst>
+                                </p:cTn>
+                              </p:par>
+                            </p:childTnLst>
+                          </p:cTn>
+                        </p:par>
+                      </p:childTnLst>
+                    </p:cTn>
+                  </p:par>
+                </p:childTnLst>
+              </p:cTn>
+              <p:prevCondLst>
+                <p:cond evt="onPrev" delay="0">
+                  <p:tgtEl>
+                    <p:sldTgt/>
+                  </p:tgtEl>
+                </p:cond>
+              </p:prevCondLst>
+              <p:nextCondLst>
+                <p:cond evt="onNext" delay="0">
+                  <p:tgtEl>
+                    <p:sldTgt/>
+                  </p:tgtEl>
+                </p:cond>
+              </p:nextCondLst>
+            </p:seq>
+          </p:childTnLst>
+        </p:cTn>
+      </p:par>
+    </p:tnLst>
+  </p:timing>
 </p:sld>
 </file>
 
@@ -13764,6 +15080,174 @@
   <p:clrMapOvr>
     <a:masterClrMapping/>
   </p:clrMapOvr>
+  <mc:AlternateContent xmlns:mc="http://schemas.openxmlformats.org/markup-compatibility/2006">
+    <mc:Choice xmlns:p14="http://schemas.microsoft.com/office/powerpoint/2010/main" Requires="p14">
+      <p:transition spd="med" p14:dur="700">
+        <p:fade/>
+      </p:transition>
+    </mc:Choice>
+    <mc:Fallback>
+      <p:transition spd="med">
+        <p:fade/>
+      </p:transition>
+    </mc:Fallback>
+  </mc:AlternateContent>
+  <p:timing>
+    <p:tnLst>
+      <p:par>
+        <p:cTn id="1" dur="indefinite" restart="never" nodeType="tmRoot">
+          <p:childTnLst>
+            <p:seq concurrent="1" nextAc="seek">
+              <p:cTn id="2" dur="indefinite" nodeType="mainSeq">
+                <p:childTnLst>
+                  <p:par>
+                    <p:cTn id="3" fill="hold">
+                      <p:stCondLst>
+                        <p:cond delay="indefinite"/>
+                        <p:cond evt="onBegin" delay="0">
+                          <p:tn val="2"/>
+                        </p:cond>
+                      </p:stCondLst>
+                      <p:childTnLst>
+                        <p:par>
+                          <p:cTn id="4" fill="hold">
+                            <p:stCondLst>
+                              <p:cond delay="0"/>
+                            </p:stCondLst>
+                            <p:childTnLst>
+                              <p:par>
+                                <p:cTn id="5" presetID="10" presetClass="entr" presetSubtype="0" fill="hold" nodeType="afterEffect">
+                                  <p:stCondLst>
+                                    <p:cond delay="0"/>
+                                  </p:stCondLst>
+                                  <p:childTnLst>
+                                    <p:set>
+                                      <p:cBhvr>
+                                        <p:cTn id="6" dur="1" fill="hold">
+                                          <p:stCondLst>
+                                            <p:cond delay="0"/>
+                                          </p:stCondLst>
+                                        </p:cTn>
+                                        <p:tgtEl>
+                                          <p:spTgt spid="4"/>
+                                        </p:tgtEl>
+                                        <p:attrNameLst>
+                                          <p:attrName>style.visibility</p:attrName>
+                                        </p:attrNameLst>
+                                      </p:cBhvr>
+                                      <p:to>
+                                        <p:strVal val="visible"/>
+                                      </p:to>
+                                    </p:set>
+                                    <p:animEffect transition="in" filter="fade">
+                                      <p:cBhvr>
+                                        <p:cTn id="7" dur="500"/>
+                                        <p:tgtEl>
+                                          <p:spTgt spid="4"/>
+                                        </p:tgtEl>
+                                      </p:cBhvr>
+                                    </p:animEffect>
+                                  </p:childTnLst>
+                                </p:cTn>
+                              </p:par>
+                              <p:par>
+                                <p:cTn id="8" presetID="10" presetClass="entr" presetSubtype="0" fill="hold" nodeType="withEffect">
+                                  <p:stCondLst>
+                                    <p:cond delay="300"/>
+                                  </p:stCondLst>
+                                  <p:childTnLst>
+                                    <p:set>
+                                      <p:cBhvr>
+                                        <p:cTn id="9" dur="1" fill="hold">
+                                          <p:stCondLst>
+                                            <p:cond delay="0"/>
+                                          </p:stCondLst>
+                                        </p:cTn>
+                                        <p:tgtEl>
+                                          <p:spTgt spid="42"/>
+                                        </p:tgtEl>
+                                        <p:attrNameLst>
+                                          <p:attrName>style.visibility</p:attrName>
+                                        </p:attrNameLst>
+                                      </p:cBhvr>
+                                      <p:to>
+                                        <p:strVal val="visible"/>
+                                      </p:to>
+                                    </p:set>
+                                    <p:animEffect transition="in" filter="fade">
+                                      <p:cBhvr>
+                                        <p:cTn id="10" dur="500"/>
+                                        <p:tgtEl>
+                                          <p:spTgt spid="42"/>
+                                        </p:tgtEl>
+                                      </p:cBhvr>
+                                    </p:animEffect>
+                                  </p:childTnLst>
+                                </p:cTn>
+                              </p:par>
+                              <p:par>
+                                <p:cTn id="11" presetID="10" presetClass="entr" presetSubtype="0" fill="hold" nodeType="withEffect">
+                                  <p:stCondLst>
+                                    <p:cond delay="600"/>
+                                  </p:stCondLst>
+                                  <p:childTnLst>
+                                    <p:set>
+                                      <p:cBhvr>
+                                        <p:cTn id="12" dur="1" fill="hold">
+                                          <p:stCondLst>
+                                            <p:cond delay="0"/>
+                                          </p:stCondLst>
+                                        </p:cTn>
+                                        <p:tgtEl>
+                                          <p:spTgt spid="43"/>
+                                        </p:tgtEl>
+                                        <p:attrNameLst>
+                                          <p:attrName>style.visibility</p:attrName>
+                                        </p:attrNameLst>
+                                      </p:cBhvr>
+                                      <p:to>
+                                        <p:strVal val="visible"/>
+                                      </p:to>
+                                    </p:set>
+                                    <p:animEffect transition="in" filter="fade">
+                                      <p:cBhvr>
+                                        <p:cTn id="13" dur="500"/>
+                                        <p:tgtEl>
+                                          <p:spTgt spid="43"/>
+                                        </p:tgtEl>
+                                      </p:cBhvr>
+                                    </p:animEffect>
+                                  </p:childTnLst>
+                                </p:cTn>
+                              </p:par>
+                            </p:childTnLst>
+                          </p:cTn>
+                        </p:par>
+                      </p:childTnLst>
+                    </p:cTn>
+                  </p:par>
+                </p:childTnLst>
+              </p:cTn>
+              <p:prevCondLst>
+                <p:cond evt="onPrev" delay="0">
+                  <p:tgtEl>
+                    <p:sldTgt/>
+                  </p:tgtEl>
+                </p:cond>
+              </p:prevCondLst>
+              <p:nextCondLst>
+                <p:cond evt="onNext" delay="0">
+                  <p:tgtEl>
+                    <p:sldTgt/>
+                  </p:tgtEl>
+                </p:cond>
+              </p:nextCondLst>
+            </p:seq>
+          </p:childTnLst>
+        </p:cTn>
+      </p:par>
+    </p:tnLst>
+  </p:timing>
 </p:sld>
 </file>
 
@@ -14398,6 +15882,174 @@
   <p:clrMapOvr>
     <a:masterClrMapping/>
   </p:clrMapOvr>
+  <mc:AlternateContent xmlns:mc="http://schemas.openxmlformats.org/markup-compatibility/2006">
+    <mc:Choice xmlns:p14="http://schemas.microsoft.com/office/powerpoint/2010/main" Requires="p14">
+      <p:transition spd="med" p14:dur="700">
+        <p:fade/>
+      </p:transition>
+    </mc:Choice>
+    <mc:Fallback>
+      <p:transition spd="med">
+        <p:fade/>
+      </p:transition>
+    </mc:Fallback>
+  </mc:AlternateContent>
+  <p:timing>
+    <p:tnLst>
+      <p:par>
+        <p:cTn id="1" dur="indefinite" restart="never" nodeType="tmRoot">
+          <p:childTnLst>
+            <p:seq concurrent="1" nextAc="seek">
+              <p:cTn id="2" dur="indefinite" nodeType="mainSeq">
+                <p:childTnLst>
+                  <p:par>
+                    <p:cTn id="3" fill="hold">
+                      <p:stCondLst>
+                        <p:cond delay="indefinite"/>
+                        <p:cond evt="onBegin" delay="0">
+                          <p:tn val="2"/>
+                        </p:cond>
+                      </p:stCondLst>
+                      <p:childTnLst>
+                        <p:par>
+                          <p:cTn id="4" fill="hold">
+                            <p:stCondLst>
+                              <p:cond delay="0"/>
+                            </p:stCondLst>
+                            <p:childTnLst>
+                              <p:par>
+                                <p:cTn id="5" presetID="10" presetClass="entr" presetSubtype="0" fill="hold" nodeType="afterEffect">
+                                  <p:stCondLst>
+                                    <p:cond delay="0"/>
+                                  </p:stCondLst>
+                                  <p:childTnLst>
+                                    <p:set>
+                                      <p:cBhvr>
+                                        <p:cTn id="6" dur="1" fill="hold">
+                                          <p:stCondLst>
+                                            <p:cond delay="0"/>
+                                          </p:stCondLst>
+                                        </p:cTn>
+                                        <p:tgtEl>
+                                          <p:spTgt spid="4"/>
+                                        </p:tgtEl>
+                                        <p:attrNameLst>
+                                          <p:attrName>style.visibility</p:attrName>
+                                        </p:attrNameLst>
+                                      </p:cBhvr>
+                                      <p:to>
+                                        <p:strVal val="visible"/>
+                                      </p:to>
+                                    </p:set>
+                                    <p:animEffect transition="in" filter="fade">
+                                      <p:cBhvr>
+                                        <p:cTn id="7" dur="500"/>
+                                        <p:tgtEl>
+                                          <p:spTgt spid="4"/>
+                                        </p:tgtEl>
+                                      </p:cBhvr>
+                                    </p:animEffect>
+                                  </p:childTnLst>
+                                </p:cTn>
+                              </p:par>
+                              <p:par>
+                                <p:cTn id="8" presetID="10" presetClass="entr" presetSubtype="0" fill="hold" nodeType="withEffect">
+                                  <p:stCondLst>
+                                    <p:cond delay="300"/>
+                                  </p:stCondLst>
+                                  <p:childTnLst>
+                                    <p:set>
+                                      <p:cBhvr>
+                                        <p:cTn id="9" dur="1" fill="hold">
+                                          <p:stCondLst>
+                                            <p:cond delay="0"/>
+                                          </p:stCondLst>
+                                        </p:cTn>
+                                        <p:tgtEl>
+                                          <p:spTgt spid="17"/>
+                                        </p:tgtEl>
+                                        <p:attrNameLst>
+                                          <p:attrName>style.visibility</p:attrName>
+                                        </p:attrNameLst>
+                                      </p:cBhvr>
+                                      <p:to>
+                                        <p:strVal val="visible"/>
+                                      </p:to>
+                                    </p:set>
+                                    <p:animEffect transition="in" filter="fade">
+                                      <p:cBhvr>
+                                        <p:cTn id="10" dur="500"/>
+                                        <p:tgtEl>
+                                          <p:spTgt spid="17"/>
+                                        </p:tgtEl>
+                                      </p:cBhvr>
+                                    </p:animEffect>
+                                  </p:childTnLst>
+                                </p:cTn>
+                              </p:par>
+                              <p:par>
+                                <p:cTn id="11" presetID="10" presetClass="entr" presetSubtype="0" fill="hold" nodeType="withEffect">
+                                  <p:stCondLst>
+                                    <p:cond delay="600"/>
+                                  </p:stCondLst>
+                                  <p:childTnLst>
+                                    <p:set>
+                                      <p:cBhvr>
+                                        <p:cTn id="12" dur="1" fill="hold">
+                                          <p:stCondLst>
+                                            <p:cond delay="0"/>
+                                          </p:stCondLst>
+                                        </p:cTn>
+                                        <p:tgtEl>
+                                          <p:spTgt spid="18"/>
+                                        </p:tgtEl>
+                                        <p:attrNameLst>
+                                          <p:attrName>style.visibility</p:attrName>
+                                        </p:attrNameLst>
+                                      </p:cBhvr>
+                                      <p:to>
+                                        <p:strVal val="visible"/>
+                                      </p:to>
+                                    </p:set>
+                                    <p:animEffect transition="in" filter="fade">
+                                      <p:cBhvr>
+                                        <p:cTn id="13" dur="500"/>
+                                        <p:tgtEl>
+                                          <p:spTgt spid="18"/>
+                                        </p:tgtEl>
+                                      </p:cBhvr>
+                                    </p:animEffect>
+                                  </p:childTnLst>
+                                </p:cTn>
+                              </p:par>
+                            </p:childTnLst>
+                          </p:cTn>
+                        </p:par>
+                      </p:childTnLst>
+                    </p:cTn>
+                  </p:par>
+                </p:childTnLst>
+              </p:cTn>
+              <p:prevCondLst>
+                <p:cond evt="onPrev" delay="0">
+                  <p:tgtEl>
+                    <p:sldTgt/>
+                  </p:tgtEl>
+                </p:cond>
+              </p:prevCondLst>
+              <p:nextCondLst>
+                <p:cond evt="onNext" delay="0">
+                  <p:tgtEl>
+                    <p:sldTgt/>
+                  </p:tgtEl>
+                </p:cond>
+              </p:nextCondLst>
+            </p:seq>
+          </p:childTnLst>
+        </p:cTn>
+      </p:par>
+    </p:tnLst>
+  </p:timing>
 </p:sld>
 </file>
 
@@ -16150,6 +17802,209 @@
   <p:clrMapOvr>
     <a:masterClrMapping/>
   </p:clrMapOvr>
+  <mc:AlternateContent xmlns:mc="http://schemas.openxmlformats.org/markup-compatibility/2006">
+    <mc:Choice xmlns:p14="http://schemas.microsoft.com/office/powerpoint/2010/main" Requires="p14">
+      <p:transition spd="med" p14:dur="700">
+        <p:fade/>
+      </p:transition>
+    </mc:Choice>
+    <mc:Fallback>
+      <p:transition spd="med">
+        <p:fade/>
+      </p:transition>
+    </mc:Fallback>
+  </mc:AlternateContent>
+  <p:timing>
+    <p:tnLst>
+      <p:par>
+        <p:cTn id="1" dur="indefinite" restart="never" nodeType="tmRoot">
+          <p:childTnLst>
+            <p:seq concurrent="1" nextAc="seek">
+              <p:cTn id="2" dur="indefinite" nodeType="mainSeq">
+                <p:childTnLst>
+                  <p:par>
+                    <p:cTn id="3" fill="hold">
+                      <p:stCondLst>
+                        <p:cond delay="indefinite"/>
+                        <p:cond evt="onBegin" delay="0">
+                          <p:tn val="2"/>
+                        </p:cond>
+                      </p:stCondLst>
+                      <p:childTnLst>
+                        <p:par>
+                          <p:cTn id="4" fill="hold">
+                            <p:stCondLst>
+                              <p:cond delay="0"/>
+                            </p:stCondLst>
+                            <p:childTnLst>
+                              <p:par>
+                                <p:cTn id="5" presetID="10" presetClass="entr" presetSubtype="0" fill="hold" nodeType="afterEffect">
+                                  <p:stCondLst>
+                                    <p:cond delay="0"/>
+                                  </p:stCondLst>
+                                  <p:childTnLst>
+                                    <p:set>
+                                      <p:cBhvr>
+                                        <p:cTn id="6" dur="1" fill="hold">
+                                          <p:stCondLst>
+                                            <p:cond delay="0"/>
+                                          </p:stCondLst>
+                                        </p:cTn>
+                                        <p:tgtEl>
+                                          <p:spTgt spid="4"/>
+                                        </p:tgtEl>
+                                        <p:attrNameLst>
+                                          <p:attrName>style.visibility</p:attrName>
+                                        </p:attrNameLst>
+                                      </p:cBhvr>
+                                      <p:to>
+                                        <p:strVal val="visible"/>
+                                      </p:to>
+                                    </p:set>
+                                    <p:animEffect transition="in" filter="fade">
+                                      <p:cBhvr>
+                                        <p:cTn id="7" dur="500"/>
+                                        <p:tgtEl>
+                                          <p:spTgt spid="4"/>
+                                        </p:tgtEl>
+                                      </p:cBhvr>
+                                    </p:animEffect>
+                                  </p:childTnLst>
+                                </p:cTn>
+                              </p:par>
+                              <p:par>
+                                <p:cTn id="8" presetID="10" presetClass="entr" presetSubtype="0" fill="hold" nodeType="withEffect">
+                                  <p:stCondLst>
+                                    <p:cond delay="300"/>
+                                  </p:stCondLst>
+                                  <p:childTnLst>
+                                    <p:set>
+                                      <p:cBhvr>
+                                        <p:cTn id="9" dur="1" fill="hold">
+                                          <p:stCondLst>
+                                            <p:cond delay="0"/>
+                                          </p:stCondLst>
+                                        </p:cTn>
+                                        <p:tgtEl>
+                                          <p:spTgt spid="52"/>
+                                        </p:tgtEl>
+                                        <p:attrNameLst>
+                                          <p:attrName>style.visibility</p:attrName>
+                                        </p:attrNameLst>
+                                      </p:cBhvr>
+                                      <p:to>
+                                        <p:strVal val="visible"/>
+                                      </p:to>
+                                    </p:set>
+                                    <p:animEffect transition="in" filter="fade">
+                                      <p:cBhvr>
+                                        <p:cTn id="10" dur="500"/>
+                                        <p:tgtEl>
+                                          <p:spTgt spid="52"/>
+                                        </p:tgtEl>
+                                      </p:cBhvr>
+                                    </p:animEffect>
+                                  </p:childTnLst>
+                                </p:cTn>
+                              </p:par>
+                              <p:par>
+                                <p:cTn id="11" presetID="10" presetClass="entr" presetSubtype="0" fill="hold" nodeType="withEffect">
+                                  <p:stCondLst>
+                                    <p:cond delay="600"/>
+                                  </p:stCondLst>
+                                  <p:childTnLst>
+                                    <p:set>
+                                      <p:cBhvr>
+                                        <p:cTn id="12" dur="1" fill="hold">
+                                          <p:stCondLst>
+                                            <p:cond delay="0"/>
+                                          </p:stCondLst>
+                                        </p:cTn>
+                                        <p:tgtEl>
+                                          <p:spTgt spid="53"/>
+                                        </p:tgtEl>
+                                        <p:attrNameLst>
+                                          <p:attrName>style.visibility</p:attrName>
+                                        </p:attrNameLst>
+                                      </p:cBhvr>
+                                      <p:to>
+                                        <p:strVal val="visible"/>
+                                      </p:to>
+                                    </p:set>
+                                    <p:animEffect transition="in" filter="fade">
+                                      <p:cBhvr>
+                                        <p:cTn id="13" dur="500"/>
+                                        <p:tgtEl>
+                                          <p:spTgt spid="53"/>
+                                        </p:tgtEl>
+                                      </p:cBhvr>
+                                    </p:animEffect>
+                                  </p:childTnLst>
+                                </p:cTn>
+                              </p:par>
+                              <p:par>
+                                <p:cTn id="14" presetID="10" presetClass="entr" presetSubtype="0" fill="hold" nodeType="withEffect">
+                                  <p:stCondLst>
+                                    <p:cond delay="900"/>
+                                  </p:stCondLst>
+                                  <p:childTnLst>
+                                    <p:set>
+                                      <p:cBhvr>
+                                        <p:cTn id="15" dur="1" fill="hold">
+                                          <p:stCondLst>
+                                            <p:cond delay="0"/>
+                                          </p:stCondLst>
+                                        </p:cTn>
+                                        <p:tgtEl>
+                                          <p:spTgt spid="54"/>
+                                        </p:tgtEl>
+                                        <p:attrNameLst>
+                                          <p:attrName>style.visibility</p:attrName>
+                                        </p:attrNameLst>
+                                      </p:cBhvr>
+                                      <p:to>
+                                        <p:strVal val="visible"/>
+                                      </p:to>
+                                    </p:set>
+                                    <p:animEffect transition="in" filter="fade">
+                                      <p:cBhvr>
+                                        <p:cTn id="16" dur="500"/>
+                                        <p:tgtEl>
+                                          <p:spTgt spid="54"/>
+                                        </p:tgtEl>
+                                      </p:cBhvr>
+                                    </p:animEffect>
+                                  </p:childTnLst>
+                                </p:cTn>
+                              </p:par>
+                            </p:childTnLst>
+                          </p:cTn>
+                        </p:par>
+                      </p:childTnLst>
+                    </p:cTn>
+                  </p:par>
+                </p:childTnLst>
+              </p:cTn>
+              <p:prevCondLst>
+                <p:cond evt="onPrev" delay="0">
+                  <p:tgtEl>
+                    <p:sldTgt/>
+                  </p:tgtEl>
+                </p:cond>
+              </p:prevCondLst>
+              <p:nextCondLst>
+                <p:cond evt="onNext" delay="0">
+                  <p:tgtEl>
+                    <p:sldTgt/>
+                  </p:tgtEl>
+                </p:cond>
+              </p:nextCondLst>
+            </p:seq>
+          </p:childTnLst>
+        </p:cTn>
+      </p:par>
+    </p:tnLst>
+  </p:timing>
 </p:sld>
 </file>
 
@@ -17719,6 +19574,209 @@
   <p:clrMapOvr>
     <a:masterClrMapping/>
   </p:clrMapOvr>
+  <mc:AlternateContent xmlns:mc="http://schemas.openxmlformats.org/markup-compatibility/2006">
+    <mc:Choice xmlns:p14="http://schemas.microsoft.com/office/powerpoint/2010/main" Requires="p14">
+      <p:transition spd="med" p14:dur="700">
+        <p:fade/>
+      </p:transition>
+    </mc:Choice>
+    <mc:Fallback>
+      <p:transition spd="med">
+        <p:fade/>
+      </p:transition>
+    </mc:Fallback>
+  </mc:AlternateContent>
+  <p:timing>
+    <p:tnLst>
+      <p:par>
+        <p:cTn id="1" dur="indefinite" restart="never" nodeType="tmRoot">
+          <p:childTnLst>
+            <p:seq concurrent="1" nextAc="seek">
+              <p:cTn id="2" dur="indefinite" nodeType="mainSeq">
+                <p:childTnLst>
+                  <p:par>
+                    <p:cTn id="3" fill="hold">
+                      <p:stCondLst>
+                        <p:cond delay="indefinite"/>
+                        <p:cond evt="onBegin" delay="0">
+                          <p:tn val="2"/>
+                        </p:cond>
+                      </p:stCondLst>
+                      <p:childTnLst>
+                        <p:par>
+                          <p:cTn id="4" fill="hold">
+                            <p:stCondLst>
+                              <p:cond delay="0"/>
+                            </p:stCondLst>
+                            <p:childTnLst>
+                              <p:par>
+                                <p:cTn id="5" presetID="10" presetClass="entr" presetSubtype="0" fill="hold" nodeType="afterEffect">
+                                  <p:stCondLst>
+                                    <p:cond delay="0"/>
+                                  </p:stCondLst>
+                                  <p:childTnLst>
+                                    <p:set>
+                                      <p:cBhvr>
+                                        <p:cTn id="6" dur="1" fill="hold">
+                                          <p:stCondLst>
+                                            <p:cond delay="0"/>
+                                          </p:stCondLst>
+                                        </p:cTn>
+                                        <p:tgtEl>
+                                          <p:spTgt spid="4"/>
+                                        </p:tgtEl>
+                                        <p:attrNameLst>
+                                          <p:attrName>style.visibility</p:attrName>
+                                        </p:attrNameLst>
+                                      </p:cBhvr>
+                                      <p:to>
+                                        <p:strVal val="visible"/>
+                                      </p:to>
+                                    </p:set>
+                                    <p:animEffect transition="in" filter="fade">
+                                      <p:cBhvr>
+                                        <p:cTn id="7" dur="500"/>
+                                        <p:tgtEl>
+                                          <p:spTgt spid="4"/>
+                                        </p:tgtEl>
+                                      </p:cBhvr>
+                                    </p:animEffect>
+                                  </p:childTnLst>
+                                </p:cTn>
+                              </p:par>
+                              <p:par>
+                                <p:cTn id="8" presetID="10" presetClass="entr" presetSubtype="0" fill="hold" nodeType="withEffect">
+                                  <p:stCondLst>
+                                    <p:cond delay="300"/>
+                                  </p:stCondLst>
+                                  <p:childTnLst>
+                                    <p:set>
+                                      <p:cBhvr>
+                                        <p:cTn id="9" dur="1" fill="hold">
+                                          <p:stCondLst>
+                                            <p:cond delay="0"/>
+                                          </p:stCondLst>
+                                        </p:cTn>
+                                        <p:tgtEl>
+                                          <p:spTgt spid="39"/>
+                                        </p:tgtEl>
+                                        <p:attrNameLst>
+                                          <p:attrName>style.visibility</p:attrName>
+                                        </p:attrNameLst>
+                                      </p:cBhvr>
+                                      <p:to>
+                                        <p:strVal val="visible"/>
+                                      </p:to>
+                                    </p:set>
+                                    <p:animEffect transition="in" filter="fade">
+                                      <p:cBhvr>
+                                        <p:cTn id="10" dur="500"/>
+                                        <p:tgtEl>
+                                          <p:spTgt spid="39"/>
+                                        </p:tgtEl>
+                                      </p:cBhvr>
+                                    </p:animEffect>
+                                  </p:childTnLst>
+                                </p:cTn>
+                              </p:par>
+                              <p:par>
+                                <p:cTn id="11" presetID="10" presetClass="entr" presetSubtype="0" fill="hold" nodeType="withEffect">
+                                  <p:stCondLst>
+                                    <p:cond delay="600"/>
+                                  </p:stCondLst>
+                                  <p:childTnLst>
+                                    <p:set>
+                                      <p:cBhvr>
+                                        <p:cTn id="12" dur="1" fill="hold">
+                                          <p:stCondLst>
+                                            <p:cond delay="0"/>
+                                          </p:stCondLst>
+                                        </p:cTn>
+                                        <p:tgtEl>
+                                          <p:spTgt spid="45"/>
+                                        </p:tgtEl>
+                                        <p:attrNameLst>
+                                          <p:attrName>style.visibility</p:attrName>
+                                        </p:attrNameLst>
+                                      </p:cBhvr>
+                                      <p:to>
+                                        <p:strVal val="visible"/>
+                                      </p:to>
+                                    </p:set>
+                                    <p:animEffect transition="in" filter="fade">
+                                      <p:cBhvr>
+                                        <p:cTn id="13" dur="500"/>
+                                        <p:tgtEl>
+                                          <p:spTgt spid="45"/>
+                                        </p:tgtEl>
+                                      </p:cBhvr>
+                                    </p:animEffect>
+                                  </p:childTnLst>
+                                </p:cTn>
+                              </p:par>
+                              <p:par>
+                                <p:cTn id="14" presetID="10" presetClass="entr" presetSubtype="0" fill="hold" nodeType="withEffect">
+                                  <p:stCondLst>
+                                    <p:cond delay="900"/>
+                                  </p:stCondLst>
+                                  <p:childTnLst>
+                                    <p:set>
+                                      <p:cBhvr>
+                                        <p:cTn id="15" dur="1" fill="hold">
+                                          <p:stCondLst>
+                                            <p:cond delay="0"/>
+                                          </p:stCondLst>
+                                        </p:cTn>
+                                        <p:tgtEl>
+                                          <p:spTgt spid="46"/>
+                                        </p:tgtEl>
+                                        <p:attrNameLst>
+                                          <p:attrName>style.visibility</p:attrName>
+                                        </p:attrNameLst>
+                                      </p:cBhvr>
+                                      <p:to>
+                                        <p:strVal val="visible"/>
+                                      </p:to>
+                                    </p:set>
+                                    <p:animEffect transition="in" filter="fade">
+                                      <p:cBhvr>
+                                        <p:cTn id="16" dur="500"/>
+                                        <p:tgtEl>
+                                          <p:spTgt spid="46"/>
+                                        </p:tgtEl>
+                                      </p:cBhvr>
+                                    </p:animEffect>
+                                  </p:childTnLst>
+                                </p:cTn>
+                              </p:par>
+                            </p:childTnLst>
+                          </p:cTn>
+                        </p:par>
+                      </p:childTnLst>
+                    </p:cTn>
+                  </p:par>
+                </p:childTnLst>
+              </p:cTn>
+              <p:prevCondLst>
+                <p:cond evt="onPrev" delay="0">
+                  <p:tgtEl>
+                    <p:sldTgt/>
+                  </p:tgtEl>
+                </p:cond>
+              </p:prevCondLst>
+              <p:nextCondLst>
+                <p:cond evt="onNext" delay="0">
+                  <p:tgtEl>
+                    <p:sldTgt/>
+                  </p:tgtEl>
+                </p:cond>
+              </p:nextCondLst>
+            </p:seq>
+          </p:childTnLst>
+        </p:cTn>
+      </p:par>
+    </p:tnLst>
+  </p:timing>
 </p:sld>
 </file>
 
@@ -18818,6 +20876,209 @@
   <p:clrMapOvr>
     <a:masterClrMapping/>
   </p:clrMapOvr>
+  <mc:AlternateContent xmlns:mc="http://schemas.openxmlformats.org/markup-compatibility/2006">
+    <mc:Choice xmlns:p14="http://schemas.microsoft.com/office/powerpoint/2010/main" Requires="p14">
+      <p:transition spd="med" p14:dur="700">
+        <p:fade/>
+      </p:transition>
+    </mc:Choice>
+    <mc:Fallback>
+      <p:transition spd="med">
+        <p:fade/>
+      </p:transition>
+    </mc:Fallback>
+  </mc:AlternateContent>
+  <p:timing>
+    <p:tnLst>
+      <p:par>
+        <p:cTn id="1" dur="indefinite" restart="never" nodeType="tmRoot">
+          <p:childTnLst>
+            <p:seq concurrent="1" nextAc="seek">
+              <p:cTn id="2" dur="indefinite" nodeType="mainSeq">
+                <p:childTnLst>
+                  <p:par>
+                    <p:cTn id="3" fill="hold">
+                      <p:stCondLst>
+                        <p:cond delay="indefinite"/>
+                        <p:cond evt="onBegin" delay="0">
+                          <p:tn val="2"/>
+                        </p:cond>
+                      </p:stCondLst>
+                      <p:childTnLst>
+                        <p:par>
+                          <p:cTn id="4" fill="hold">
+                            <p:stCondLst>
+                              <p:cond delay="0"/>
+                            </p:stCondLst>
+                            <p:childTnLst>
+                              <p:par>
+                                <p:cTn id="5" presetID="10" presetClass="entr" presetSubtype="0" fill="hold" nodeType="afterEffect">
+                                  <p:stCondLst>
+                                    <p:cond delay="0"/>
+                                  </p:stCondLst>
+                                  <p:childTnLst>
+                                    <p:set>
+                                      <p:cBhvr>
+                                        <p:cTn id="6" dur="1" fill="hold">
+                                          <p:stCondLst>
+                                            <p:cond delay="0"/>
+                                          </p:stCondLst>
+                                        </p:cTn>
+                                        <p:tgtEl>
+                                          <p:spTgt spid="3"/>
+                                        </p:tgtEl>
+                                        <p:attrNameLst>
+                                          <p:attrName>style.visibility</p:attrName>
+                                        </p:attrNameLst>
+                                      </p:cBhvr>
+                                      <p:to>
+                                        <p:strVal val="visible"/>
+                                      </p:to>
+                                    </p:set>
+                                    <p:animEffect transition="in" filter="fade">
+                                      <p:cBhvr>
+                                        <p:cTn id="7" dur="500"/>
+                                        <p:tgtEl>
+                                          <p:spTgt spid="3"/>
+                                        </p:tgtEl>
+                                      </p:cBhvr>
+                                    </p:animEffect>
+                                  </p:childTnLst>
+                                </p:cTn>
+                              </p:par>
+                              <p:par>
+                                <p:cTn id="8" presetID="10" presetClass="entr" presetSubtype="0" fill="hold" nodeType="withEffect">
+                                  <p:stCondLst>
+                                    <p:cond delay="300"/>
+                                  </p:stCondLst>
+                                  <p:childTnLst>
+                                    <p:set>
+                                      <p:cBhvr>
+                                        <p:cTn id="9" dur="1" fill="hold">
+                                          <p:stCondLst>
+                                            <p:cond delay="0"/>
+                                          </p:stCondLst>
+                                        </p:cTn>
+                                        <p:tgtEl>
+                                          <p:spTgt spid="19"/>
+                                        </p:tgtEl>
+                                        <p:attrNameLst>
+                                          <p:attrName>style.visibility</p:attrName>
+                                        </p:attrNameLst>
+                                      </p:cBhvr>
+                                      <p:to>
+                                        <p:strVal val="visible"/>
+                                      </p:to>
+                                    </p:set>
+                                    <p:animEffect transition="in" filter="fade">
+                                      <p:cBhvr>
+                                        <p:cTn id="10" dur="500"/>
+                                        <p:tgtEl>
+                                          <p:spTgt spid="19"/>
+                                        </p:tgtEl>
+                                      </p:cBhvr>
+                                    </p:animEffect>
+                                  </p:childTnLst>
+                                </p:cTn>
+                              </p:par>
+                              <p:par>
+                                <p:cTn id="11" presetID="10" presetClass="entr" presetSubtype="0" fill="hold" nodeType="withEffect">
+                                  <p:stCondLst>
+                                    <p:cond delay="600"/>
+                                  </p:stCondLst>
+                                  <p:childTnLst>
+                                    <p:set>
+                                      <p:cBhvr>
+                                        <p:cTn id="12" dur="1" fill="hold">
+                                          <p:stCondLst>
+                                            <p:cond delay="0"/>
+                                          </p:stCondLst>
+                                        </p:cTn>
+                                        <p:tgtEl>
+                                          <p:spTgt spid="29"/>
+                                        </p:tgtEl>
+                                        <p:attrNameLst>
+                                          <p:attrName>style.visibility</p:attrName>
+                                        </p:attrNameLst>
+                                      </p:cBhvr>
+                                      <p:to>
+                                        <p:strVal val="visible"/>
+                                      </p:to>
+                                    </p:set>
+                                    <p:animEffect transition="in" filter="fade">
+                                      <p:cBhvr>
+                                        <p:cTn id="13" dur="500"/>
+                                        <p:tgtEl>
+                                          <p:spTgt spid="29"/>
+                                        </p:tgtEl>
+                                      </p:cBhvr>
+                                    </p:animEffect>
+                                  </p:childTnLst>
+                                </p:cTn>
+                              </p:par>
+                              <p:par>
+                                <p:cTn id="14" presetID="10" presetClass="entr" presetSubtype="0" fill="hold" nodeType="withEffect">
+                                  <p:stCondLst>
+                                    <p:cond delay="900"/>
+                                  </p:stCondLst>
+                                  <p:childTnLst>
+                                    <p:set>
+                                      <p:cBhvr>
+                                        <p:cTn id="15" dur="1" fill="hold">
+                                          <p:stCondLst>
+                                            <p:cond delay="0"/>
+                                          </p:stCondLst>
+                                        </p:cTn>
+                                        <p:tgtEl>
+                                          <p:spTgt spid="30"/>
+                                        </p:tgtEl>
+                                        <p:attrNameLst>
+                                          <p:attrName>style.visibility</p:attrName>
+                                        </p:attrNameLst>
+                                      </p:cBhvr>
+                                      <p:to>
+                                        <p:strVal val="visible"/>
+                                      </p:to>
+                                    </p:set>
+                                    <p:animEffect transition="in" filter="fade">
+                                      <p:cBhvr>
+                                        <p:cTn id="16" dur="500"/>
+                                        <p:tgtEl>
+                                          <p:spTgt spid="30"/>
+                                        </p:tgtEl>
+                                      </p:cBhvr>
+                                    </p:animEffect>
+                                  </p:childTnLst>
+                                </p:cTn>
+                              </p:par>
+                            </p:childTnLst>
+                          </p:cTn>
+                        </p:par>
+                      </p:childTnLst>
+                    </p:cTn>
+                  </p:par>
+                </p:childTnLst>
+              </p:cTn>
+              <p:prevCondLst>
+                <p:cond evt="onPrev" delay="0">
+                  <p:tgtEl>
+                    <p:sldTgt/>
+                  </p:tgtEl>
+                </p:cond>
+              </p:prevCondLst>
+              <p:nextCondLst>
+                <p:cond evt="onNext" delay="0">
+                  <p:tgtEl>
+                    <p:sldTgt/>
+                  </p:tgtEl>
+                </p:cond>
+              </p:nextCondLst>
+            </p:seq>
+          </p:childTnLst>
+        </p:cTn>
+      </p:par>
+    </p:tnLst>
+  </p:timing>
 </p:sld>
 </file>
 
@@ -19571,6 +21832,209 @@
   <p:clrMapOvr>
     <a:masterClrMapping/>
   </p:clrMapOvr>
+  <mc:AlternateContent xmlns:mc="http://schemas.openxmlformats.org/markup-compatibility/2006">
+    <mc:Choice xmlns:p14="http://schemas.microsoft.com/office/powerpoint/2010/main" Requires="p14">
+      <p:transition spd="med" p14:dur="700">
+        <p:fade/>
+      </p:transition>
+    </mc:Choice>
+    <mc:Fallback>
+      <p:transition spd="med">
+        <p:fade/>
+      </p:transition>
+    </mc:Fallback>
+  </mc:AlternateContent>
+  <p:timing>
+    <p:tnLst>
+      <p:par>
+        <p:cTn id="1" dur="indefinite" restart="never" nodeType="tmRoot">
+          <p:childTnLst>
+            <p:seq concurrent="1" nextAc="seek">
+              <p:cTn id="2" dur="indefinite" nodeType="mainSeq">
+                <p:childTnLst>
+                  <p:par>
+                    <p:cTn id="3" fill="hold">
+                      <p:stCondLst>
+                        <p:cond delay="indefinite"/>
+                        <p:cond evt="onBegin" delay="0">
+                          <p:tn val="2"/>
+                        </p:cond>
+                      </p:stCondLst>
+                      <p:childTnLst>
+                        <p:par>
+                          <p:cTn id="4" fill="hold">
+                            <p:stCondLst>
+                              <p:cond delay="0"/>
+                            </p:stCondLst>
+                            <p:childTnLst>
+                              <p:par>
+                                <p:cTn id="5" presetID="10" presetClass="entr" presetSubtype="0" fill="hold" nodeType="afterEffect">
+                                  <p:stCondLst>
+                                    <p:cond delay="0"/>
+                                  </p:stCondLst>
+                                  <p:childTnLst>
+                                    <p:set>
+                                      <p:cBhvr>
+                                        <p:cTn id="6" dur="1" fill="hold">
+                                          <p:stCondLst>
+                                            <p:cond delay="0"/>
+                                          </p:stCondLst>
+                                        </p:cTn>
+                                        <p:tgtEl>
+                                          <p:spTgt spid="4"/>
+                                        </p:tgtEl>
+                                        <p:attrNameLst>
+                                          <p:attrName>style.visibility</p:attrName>
+                                        </p:attrNameLst>
+                                      </p:cBhvr>
+                                      <p:to>
+                                        <p:strVal val="visible"/>
+                                      </p:to>
+                                    </p:set>
+                                    <p:animEffect transition="in" filter="fade">
+                                      <p:cBhvr>
+                                        <p:cTn id="7" dur="500"/>
+                                        <p:tgtEl>
+                                          <p:spTgt spid="4"/>
+                                        </p:tgtEl>
+                                      </p:cBhvr>
+                                    </p:animEffect>
+                                  </p:childTnLst>
+                                </p:cTn>
+                              </p:par>
+                              <p:par>
+                                <p:cTn id="8" presetID="10" presetClass="entr" presetSubtype="0" fill="hold" nodeType="withEffect">
+                                  <p:stCondLst>
+                                    <p:cond delay="300"/>
+                                  </p:stCondLst>
+                                  <p:childTnLst>
+                                    <p:set>
+                                      <p:cBhvr>
+                                        <p:cTn id="9" dur="1" fill="hold">
+                                          <p:stCondLst>
+                                            <p:cond delay="0"/>
+                                          </p:stCondLst>
+                                        </p:cTn>
+                                        <p:tgtEl>
+                                          <p:spTgt spid="19"/>
+                                        </p:tgtEl>
+                                        <p:attrNameLst>
+                                          <p:attrName>style.visibility</p:attrName>
+                                        </p:attrNameLst>
+                                      </p:cBhvr>
+                                      <p:to>
+                                        <p:strVal val="visible"/>
+                                      </p:to>
+                                    </p:set>
+                                    <p:animEffect transition="in" filter="fade">
+                                      <p:cBhvr>
+                                        <p:cTn id="10" dur="500"/>
+                                        <p:tgtEl>
+                                          <p:spTgt spid="19"/>
+                                        </p:tgtEl>
+                                      </p:cBhvr>
+                                    </p:animEffect>
+                                  </p:childTnLst>
+                                </p:cTn>
+                              </p:par>
+                              <p:par>
+                                <p:cTn id="11" presetID="10" presetClass="entr" presetSubtype="0" fill="hold" nodeType="withEffect">
+                                  <p:stCondLst>
+                                    <p:cond delay="600"/>
+                                  </p:stCondLst>
+                                  <p:childTnLst>
+                                    <p:set>
+                                      <p:cBhvr>
+                                        <p:cTn id="12" dur="1" fill="hold">
+                                          <p:stCondLst>
+                                            <p:cond delay="0"/>
+                                          </p:stCondLst>
+                                        </p:cTn>
+                                        <p:tgtEl>
+                                          <p:spTgt spid="20"/>
+                                        </p:tgtEl>
+                                        <p:attrNameLst>
+                                          <p:attrName>style.visibility</p:attrName>
+                                        </p:attrNameLst>
+                                      </p:cBhvr>
+                                      <p:to>
+                                        <p:strVal val="visible"/>
+                                      </p:to>
+                                    </p:set>
+                                    <p:animEffect transition="in" filter="fade">
+                                      <p:cBhvr>
+                                        <p:cTn id="13" dur="500"/>
+                                        <p:tgtEl>
+                                          <p:spTgt spid="20"/>
+                                        </p:tgtEl>
+                                      </p:cBhvr>
+                                    </p:animEffect>
+                                  </p:childTnLst>
+                                </p:cTn>
+                              </p:par>
+                              <p:par>
+                                <p:cTn id="14" presetID="10" presetClass="entr" presetSubtype="0" fill="hold" nodeType="withEffect">
+                                  <p:stCondLst>
+                                    <p:cond delay="900"/>
+                                  </p:stCondLst>
+                                  <p:childTnLst>
+                                    <p:set>
+                                      <p:cBhvr>
+                                        <p:cTn id="15" dur="1" fill="hold">
+                                          <p:stCondLst>
+                                            <p:cond delay="0"/>
+                                          </p:stCondLst>
+                                        </p:cTn>
+                                        <p:tgtEl>
+                                          <p:spTgt spid="21"/>
+                                        </p:tgtEl>
+                                        <p:attrNameLst>
+                                          <p:attrName>style.visibility</p:attrName>
+                                        </p:attrNameLst>
+                                      </p:cBhvr>
+                                      <p:to>
+                                        <p:strVal val="visible"/>
+                                      </p:to>
+                                    </p:set>
+                                    <p:animEffect transition="in" filter="fade">
+                                      <p:cBhvr>
+                                        <p:cTn id="16" dur="500"/>
+                                        <p:tgtEl>
+                                          <p:spTgt spid="21"/>
+                                        </p:tgtEl>
+                                      </p:cBhvr>
+                                    </p:animEffect>
+                                  </p:childTnLst>
+                                </p:cTn>
+                              </p:par>
+                            </p:childTnLst>
+                          </p:cTn>
+                        </p:par>
+                      </p:childTnLst>
+                    </p:cTn>
+                  </p:par>
+                </p:childTnLst>
+              </p:cTn>
+              <p:prevCondLst>
+                <p:cond evt="onPrev" delay="0">
+                  <p:tgtEl>
+                    <p:sldTgt/>
+                  </p:tgtEl>
+                </p:cond>
+              </p:prevCondLst>
+              <p:nextCondLst>
+                <p:cond evt="onNext" delay="0">
+                  <p:tgtEl>
+                    <p:sldTgt/>
+                  </p:tgtEl>
+                </p:cond>
+              </p:nextCondLst>
+            </p:seq>
+          </p:childTnLst>
+        </p:cTn>
+      </p:par>
+    </p:tnLst>
+  </p:timing>
 </p:sld>
 </file>
 
@@ -21225,6 +23689,174 @@
   <p:clrMapOvr>
     <a:masterClrMapping/>
   </p:clrMapOvr>
+  <mc:AlternateContent xmlns:mc="http://schemas.openxmlformats.org/markup-compatibility/2006">
+    <mc:Choice xmlns:p14="http://schemas.microsoft.com/office/powerpoint/2010/main" Requires="p14">
+      <p:transition spd="med" p14:dur="700">
+        <p:fade/>
+      </p:transition>
+    </mc:Choice>
+    <mc:Fallback>
+      <p:transition spd="med">
+        <p:fade/>
+      </p:transition>
+    </mc:Fallback>
+  </mc:AlternateContent>
+  <p:timing>
+    <p:tnLst>
+      <p:par>
+        <p:cTn id="1" dur="indefinite" restart="never" nodeType="tmRoot">
+          <p:childTnLst>
+            <p:seq concurrent="1" nextAc="seek">
+              <p:cTn id="2" dur="indefinite" nodeType="mainSeq">
+                <p:childTnLst>
+                  <p:par>
+                    <p:cTn id="3" fill="hold">
+                      <p:stCondLst>
+                        <p:cond delay="indefinite"/>
+                        <p:cond evt="onBegin" delay="0">
+                          <p:tn val="2"/>
+                        </p:cond>
+                      </p:stCondLst>
+                      <p:childTnLst>
+                        <p:par>
+                          <p:cTn id="4" fill="hold">
+                            <p:stCondLst>
+                              <p:cond delay="0"/>
+                            </p:stCondLst>
+                            <p:childTnLst>
+                              <p:par>
+                                <p:cTn id="5" presetID="10" presetClass="entr" presetSubtype="0" fill="hold" nodeType="afterEffect">
+                                  <p:stCondLst>
+                                    <p:cond delay="0"/>
+                                  </p:stCondLst>
+                                  <p:childTnLst>
+                                    <p:set>
+                                      <p:cBhvr>
+                                        <p:cTn id="6" dur="1" fill="hold">
+                                          <p:stCondLst>
+                                            <p:cond delay="0"/>
+                                          </p:stCondLst>
+                                        </p:cTn>
+                                        <p:tgtEl>
+                                          <p:spTgt spid="4"/>
+                                        </p:tgtEl>
+                                        <p:attrNameLst>
+                                          <p:attrName>style.visibility</p:attrName>
+                                        </p:attrNameLst>
+                                      </p:cBhvr>
+                                      <p:to>
+                                        <p:strVal val="visible"/>
+                                      </p:to>
+                                    </p:set>
+                                    <p:animEffect transition="in" filter="fade">
+                                      <p:cBhvr>
+                                        <p:cTn id="7" dur="500"/>
+                                        <p:tgtEl>
+                                          <p:spTgt spid="4"/>
+                                        </p:tgtEl>
+                                      </p:cBhvr>
+                                    </p:animEffect>
+                                  </p:childTnLst>
+                                </p:cTn>
+                              </p:par>
+                              <p:par>
+                                <p:cTn id="8" presetID="10" presetClass="entr" presetSubtype="0" fill="hold" nodeType="withEffect">
+                                  <p:stCondLst>
+                                    <p:cond delay="300"/>
+                                  </p:stCondLst>
+                                  <p:childTnLst>
+                                    <p:set>
+                                      <p:cBhvr>
+                                        <p:cTn id="9" dur="1" fill="hold">
+                                          <p:stCondLst>
+                                            <p:cond delay="0"/>
+                                          </p:stCondLst>
+                                        </p:cTn>
+                                        <p:tgtEl>
+                                          <p:spTgt spid="51"/>
+                                        </p:tgtEl>
+                                        <p:attrNameLst>
+                                          <p:attrName>style.visibility</p:attrName>
+                                        </p:attrNameLst>
+                                      </p:cBhvr>
+                                      <p:to>
+                                        <p:strVal val="visible"/>
+                                      </p:to>
+                                    </p:set>
+                                    <p:animEffect transition="in" filter="fade">
+                                      <p:cBhvr>
+                                        <p:cTn id="10" dur="500"/>
+                                        <p:tgtEl>
+                                          <p:spTgt spid="51"/>
+                                        </p:tgtEl>
+                                      </p:cBhvr>
+                                    </p:animEffect>
+                                  </p:childTnLst>
+                                </p:cTn>
+                              </p:par>
+                              <p:par>
+                                <p:cTn id="11" presetID="10" presetClass="entr" presetSubtype="0" fill="hold" nodeType="withEffect">
+                                  <p:stCondLst>
+                                    <p:cond delay="600"/>
+                                  </p:stCondLst>
+                                  <p:childTnLst>
+                                    <p:set>
+                                      <p:cBhvr>
+                                        <p:cTn id="12" dur="1" fill="hold">
+                                          <p:stCondLst>
+                                            <p:cond delay="0"/>
+                                          </p:stCondLst>
+                                        </p:cTn>
+                                        <p:tgtEl>
+                                          <p:spTgt spid="52"/>
+                                        </p:tgtEl>
+                                        <p:attrNameLst>
+                                          <p:attrName>style.visibility</p:attrName>
+                                        </p:attrNameLst>
+                                      </p:cBhvr>
+                                      <p:to>
+                                        <p:strVal val="visible"/>
+                                      </p:to>
+                                    </p:set>
+                                    <p:animEffect transition="in" filter="fade">
+                                      <p:cBhvr>
+                                        <p:cTn id="13" dur="500"/>
+                                        <p:tgtEl>
+                                          <p:spTgt spid="52"/>
+                                        </p:tgtEl>
+                                      </p:cBhvr>
+                                    </p:animEffect>
+                                  </p:childTnLst>
+                                </p:cTn>
+                              </p:par>
+                            </p:childTnLst>
+                          </p:cTn>
+                        </p:par>
+                      </p:childTnLst>
+                    </p:cTn>
+                  </p:par>
+                </p:childTnLst>
+              </p:cTn>
+              <p:prevCondLst>
+                <p:cond evt="onPrev" delay="0">
+                  <p:tgtEl>
+                    <p:sldTgt/>
+                  </p:tgtEl>
+                </p:cond>
+              </p:prevCondLst>
+              <p:nextCondLst>
+                <p:cond evt="onNext" delay="0">
+                  <p:tgtEl>
+                    <p:sldTgt/>
+                  </p:tgtEl>
+                </p:cond>
+              </p:nextCondLst>
+            </p:seq>
+          </p:childTnLst>
+        </p:cTn>
+      </p:par>
+    </p:tnLst>
+  </p:timing>
 </p:sld>
 </file>
 
@@ -23180,6 +25812,209 @@
   <p:clrMapOvr>
     <a:masterClrMapping/>
   </p:clrMapOvr>
+  <mc:AlternateContent xmlns:mc="http://schemas.openxmlformats.org/markup-compatibility/2006">
+    <mc:Choice xmlns:p14="http://schemas.microsoft.com/office/powerpoint/2010/main" Requires="p14">
+      <p:transition spd="med" p14:dur="700">
+        <p:fade/>
+      </p:transition>
+    </mc:Choice>
+    <mc:Fallback>
+      <p:transition spd="med">
+        <p:fade/>
+      </p:transition>
+    </mc:Fallback>
+  </mc:AlternateContent>
+  <p:timing>
+    <p:tnLst>
+      <p:par>
+        <p:cTn id="1" dur="indefinite" restart="never" nodeType="tmRoot">
+          <p:childTnLst>
+            <p:seq concurrent="1" nextAc="seek">
+              <p:cTn id="2" dur="indefinite" nodeType="mainSeq">
+                <p:childTnLst>
+                  <p:par>
+                    <p:cTn id="3" fill="hold">
+                      <p:stCondLst>
+                        <p:cond delay="indefinite"/>
+                        <p:cond evt="onBegin" delay="0">
+                          <p:tn val="2"/>
+                        </p:cond>
+                      </p:stCondLst>
+                      <p:childTnLst>
+                        <p:par>
+                          <p:cTn id="4" fill="hold">
+                            <p:stCondLst>
+                              <p:cond delay="0"/>
+                            </p:stCondLst>
+                            <p:childTnLst>
+                              <p:par>
+                                <p:cTn id="5" presetID="10" presetClass="entr" presetSubtype="0" fill="hold" nodeType="afterEffect">
+                                  <p:stCondLst>
+                                    <p:cond delay="0"/>
+                                  </p:stCondLst>
+                                  <p:childTnLst>
+                                    <p:set>
+                                      <p:cBhvr>
+                                        <p:cTn id="6" dur="1" fill="hold">
+                                          <p:stCondLst>
+                                            <p:cond delay="0"/>
+                                          </p:stCondLst>
+                                        </p:cTn>
+                                        <p:tgtEl>
+                                          <p:spTgt spid="4"/>
+                                        </p:tgtEl>
+                                        <p:attrNameLst>
+                                          <p:attrName>style.visibility</p:attrName>
+                                        </p:attrNameLst>
+                                      </p:cBhvr>
+                                      <p:to>
+                                        <p:strVal val="visible"/>
+                                      </p:to>
+                                    </p:set>
+                                    <p:animEffect transition="in" filter="fade">
+                                      <p:cBhvr>
+                                        <p:cTn id="7" dur="500"/>
+                                        <p:tgtEl>
+                                          <p:spTgt spid="4"/>
+                                        </p:tgtEl>
+                                      </p:cBhvr>
+                                    </p:animEffect>
+                                  </p:childTnLst>
+                                </p:cTn>
+                              </p:par>
+                              <p:par>
+                                <p:cTn id="8" presetID="10" presetClass="entr" presetSubtype="0" fill="hold" nodeType="withEffect">
+                                  <p:stCondLst>
+                                    <p:cond delay="300"/>
+                                  </p:stCondLst>
+                                  <p:childTnLst>
+                                    <p:set>
+                                      <p:cBhvr>
+                                        <p:cTn id="9" dur="1" fill="hold">
+                                          <p:stCondLst>
+                                            <p:cond delay="0"/>
+                                          </p:stCondLst>
+                                        </p:cTn>
+                                        <p:tgtEl>
+                                          <p:spTgt spid="59"/>
+                                        </p:tgtEl>
+                                        <p:attrNameLst>
+                                          <p:attrName>style.visibility</p:attrName>
+                                        </p:attrNameLst>
+                                      </p:cBhvr>
+                                      <p:to>
+                                        <p:strVal val="visible"/>
+                                      </p:to>
+                                    </p:set>
+                                    <p:animEffect transition="in" filter="fade">
+                                      <p:cBhvr>
+                                        <p:cTn id="10" dur="500"/>
+                                        <p:tgtEl>
+                                          <p:spTgt spid="59"/>
+                                        </p:tgtEl>
+                                      </p:cBhvr>
+                                    </p:animEffect>
+                                  </p:childTnLst>
+                                </p:cTn>
+                              </p:par>
+                              <p:par>
+                                <p:cTn id="11" presetID="10" presetClass="entr" presetSubtype="0" fill="hold" nodeType="withEffect">
+                                  <p:stCondLst>
+                                    <p:cond delay="600"/>
+                                  </p:stCondLst>
+                                  <p:childTnLst>
+                                    <p:set>
+                                      <p:cBhvr>
+                                        <p:cTn id="12" dur="1" fill="hold">
+                                          <p:stCondLst>
+                                            <p:cond delay="0"/>
+                                          </p:stCondLst>
+                                        </p:cTn>
+                                        <p:tgtEl>
+                                          <p:spTgt spid="60"/>
+                                        </p:tgtEl>
+                                        <p:attrNameLst>
+                                          <p:attrName>style.visibility</p:attrName>
+                                        </p:attrNameLst>
+                                      </p:cBhvr>
+                                      <p:to>
+                                        <p:strVal val="visible"/>
+                                      </p:to>
+                                    </p:set>
+                                    <p:animEffect transition="in" filter="fade">
+                                      <p:cBhvr>
+                                        <p:cTn id="13" dur="500"/>
+                                        <p:tgtEl>
+                                          <p:spTgt spid="60"/>
+                                        </p:tgtEl>
+                                      </p:cBhvr>
+                                    </p:animEffect>
+                                  </p:childTnLst>
+                                </p:cTn>
+                              </p:par>
+                              <p:par>
+                                <p:cTn id="14" presetID="10" presetClass="entr" presetSubtype="0" fill="hold" nodeType="withEffect">
+                                  <p:stCondLst>
+                                    <p:cond delay="900"/>
+                                  </p:stCondLst>
+                                  <p:childTnLst>
+                                    <p:set>
+                                      <p:cBhvr>
+                                        <p:cTn id="15" dur="1" fill="hold">
+                                          <p:stCondLst>
+                                            <p:cond delay="0"/>
+                                          </p:stCondLst>
+                                        </p:cTn>
+                                        <p:tgtEl>
+                                          <p:spTgt spid="61"/>
+                                        </p:tgtEl>
+                                        <p:attrNameLst>
+                                          <p:attrName>style.visibility</p:attrName>
+                                        </p:attrNameLst>
+                                      </p:cBhvr>
+                                      <p:to>
+                                        <p:strVal val="visible"/>
+                                      </p:to>
+                                    </p:set>
+                                    <p:animEffect transition="in" filter="fade">
+                                      <p:cBhvr>
+                                        <p:cTn id="16" dur="500"/>
+                                        <p:tgtEl>
+                                          <p:spTgt spid="61"/>
+                                        </p:tgtEl>
+                                      </p:cBhvr>
+                                    </p:animEffect>
+                                  </p:childTnLst>
+                                </p:cTn>
+                              </p:par>
+                            </p:childTnLst>
+                          </p:cTn>
+                        </p:par>
+                      </p:childTnLst>
+                    </p:cTn>
+                  </p:par>
+                </p:childTnLst>
+              </p:cTn>
+              <p:prevCondLst>
+                <p:cond evt="onPrev" delay="0">
+                  <p:tgtEl>
+                    <p:sldTgt/>
+                  </p:tgtEl>
+                </p:cond>
+              </p:prevCondLst>
+              <p:nextCondLst>
+                <p:cond evt="onNext" delay="0">
+                  <p:tgtEl>
+                    <p:sldTgt/>
+                  </p:tgtEl>
+                </p:cond>
+              </p:nextCondLst>
+            </p:seq>
+          </p:childTnLst>
+        </p:cTn>
+      </p:par>
+    </p:tnLst>
+  </p:timing>
 </p:sld>
 </file>
 
@@ -24439,6 +27274,209 @@
   <p:clrMapOvr>
     <a:masterClrMapping/>
   </p:clrMapOvr>
+  <mc:AlternateContent xmlns:mc="http://schemas.openxmlformats.org/markup-compatibility/2006">
+    <mc:Choice xmlns:p14="http://schemas.microsoft.com/office/powerpoint/2010/main" Requires="p14">
+      <p:transition spd="med" p14:dur="700">
+        <p:fade/>
+      </p:transition>
+    </mc:Choice>
+    <mc:Fallback>
+      <p:transition spd="med">
+        <p:fade/>
+      </p:transition>
+    </mc:Fallback>
+  </mc:AlternateContent>
+  <p:timing>
+    <p:tnLst>
+      <p:par>
+        <p:cTn id="1" dur="indefinite" restart="never" nodeType="tmRoot">
+          <p:childTnLst>
+            <p:seq concurrent="1" nextAc="seek">
+              <p:cTn id="2" dur="indefinite" nodeType="mainSeq">
+                <p:childTnLst>
+                  <p:par>
+                    <p:cTn id="3" fill="hold">
+                      <p:stCondLst>
+                        <p:cond delay="indefinite"/>
+                        <p:cond evt="onBegin" delay="0">
+                          <p:tn val="2"/>
+                        </p:cond>
+                      </p:stCondLst>
+                      <p:childTnLst>
+                        <p:par>
+                          <p:cTn id="4" fill="hold">
+                            <p:stCondLst>
+                              <p:cond delay="0"/>
+                            </p:stCondLst>
+                            <p:childTnLst>
+                              <p:par>
+                                <p:cTn id="5" presetID="10" presetClass="entr" presetSubtype="0" fill="hold" nodeType="afterEffect">
+                                  <p:stCondLst>
+                                    <p:cond delay="0"/>
+                                  </p:stCondLst>
+                                  <p:childTnLst>
+                                    <p:set>
+                                      <p:cBhvr>
+                                        <p:cTn id="6" dur="1" fill="hold">
+                                          <p:stCondLst>
+                                            <p:cond delay="0"/>
+                                          </p:stCondLst>
+                                        </p:cTn>
+                                        <p:tgtEl>
+                                          <p:spTgt spid="4"/>
+                                        </p:tgtEl>
+                                        <p:attrNameLst>
+                                          <p:attrName>style.visibility</p:attrName>
+                                        </p:attrNameLst>
+                                      </p:cBhvr>
+                                      <p:to>
+                                        <p:strVal val="visible"/>
+                                      </p:to>
+                                    </p:set>
+                                    <p:animEffect transition="in" filter="fade">
+                                      <p:cBhvr>
+                                        <p:cTn id="7" dur="500"/>
+                                        <p:tgtEl>
+                                          <p:spTgt spid="4"/>
+                                        </p:tgtEl>
+                                      </p:cBhvr>
+                                    </p:animEffect>
+                                  </p:childTnLst>
+                                </p:cTn>
+                              </p:par>
+                              <p:par>
+                                <p:cTn id="8" presetID="10" presetClass="entr" presetSubtype="0" fill="hold" nodeType="withEffect">
+                                  <p:stCondLst>
+                                    <p:cond delay="300"/>
+                                  </p:stCondLst>
+                                  <p:childTnLst>
+                                    <p:set>
+                                      <p:cBhvr>
+                                        <p:cTn id="9" dur="1" fill="hold">
+                                          <p:stCondLst>
+                                            <p:cond delay="0"/>
+                                          </p:stCondLst>
+                                        </p:cTn>
+                                        <p:tgtEl>
+                                          <p:spTgt spid="32"/>
+                                        </p:tgtEl>
+                                        <p:attrNameLst>
+                                          <p:attrName>style.visibility</p:attrName>
+                                        </p:attrNameLst>
+                                      </p:cBhvr>
+                                      <p:to>
+                                        <p:strVal val="visible"/>
+                                      </p:to>
+                                    </p:set>
+                                    <p:animEffect transition="in" filter="fade">
+                                      <p:cBhvr>
+                                        <p:cTn id="10" dur="500"/>
+                                        <p:tgtEl>
+                                          <p:spTgt spid="32"/>
+                                        </p:tgtEl>
+                                      </p:cBhvr>
+                                    </p:animEffect>
+                                  </p:childTnLst>
+                                </p:cTn>
+                              </p:par>
+                              <p:par>
+                                <p:cTn id="11" presetID="10" presetClass="entr" presetSubtype="0" fill="hold" nodeType="withEffect">
+                                  <p:stCondLst>
+                                    <p:cond delay="600"/>
+                                  </p:stCondLst>
+                                  <p:childTnLst>
+                                    <p:set>
+                                      <p:cBhvr>
+                                        <p:cTn id="12" dur="1" fill="hold">
+                                          <p:stCondLst>
+                                            <p:cond delay="0"/>
+                                          </p:stCondLst>
+                                        </p:cTn>
+                                        <p:tgtEl>
+                                          <p:spTgt spid="33"/>
+                                        </p:tgtEl>
+                                        <p:attrNameLst>
+                                          <p:attrName>style.visibility</p:attrName>
+                                        </p:attrNameLst>
+                                      </p:cBhvr>
+                                      <p:to>
+                                        <p:strVal val="visible"/>
+                                      </p:to>
+                                    </p:set>
+                                    <p:animEffect transition="in" filter="fade">
+                                      <p:cBhvr>
+                                        <p:cTn id="13" dur="500"/>
+                                        <p:tgtEl>
+                                          <p:spTgt spid="33"/>
+                                        </p:tgtEl>
+                                      </p:cBhvr>
+                                    </p:animEffect>
+                                  </p:childTnLst>
+                                </p:cTn>
+                              </p:par>
+                              <p:par>
+                                <p:cTn id="14" presetID="10" presetClass="entr" presetSubtype="0" fill="hold" nodeType="withEffect">
+                                  <p:stCondLst>
+                                    <p:cond delay="900"/>
+                                  </p:stCondLst>
+                                  <p:childTnLst>
+                                    <p:set>
+                                      <p:cBhvr>
+                                        <p:cTn id="15" dur="1" fill="hold">
+                                          <p:stCondLst>
+                                            <p:cond delay="0"/>
+                                          </p:stCondLst>
+                                        </p:cTn>
+                                        <p:tgtEl>
+                                          <p:spTgt spid="34"/>
+                                        </p:tgtEl>
+                                        <p:attrNameLst>
+                                          <p:attrName>style.visibility</p:attrName>
+                                        </p:attrNameLst>
+                                      </p:cBhvr>
+                                      <p:to>
+                                        <p:strVal val="visible"/>
+                                      </p:to>
+                                    </p:set>
+                                    <p:animEffect transition="in" filter="fade">
+                                      <p:cBhvr>
+                                        <p:cTn id="16" dur="500"/>
+                                        <p:tgtEl>
+                                          <p:spTgt spid="34"/>
+                                        </p:tgtEl>
+                                      </p:cBhvr>
+                                    </p:animEffect>
+                                  </p:childTnLst>
+                                </p:cTn>
+                              </p:par>
+                            </p:childTnLst>
+                          </p:cTn>
+                        </p:par>
+                      </p:childTnLst>
+                    </p:cTn>
+                  </p:par>
+                </p:childTnLst>
+              </p:cTn>
+              <p:prevCondLst>
+                <p:cond evt="onPrev" delay="0">
+                  <p:tgtEl>
+                    <p:sldTgt/>
+                  </p:tgtEl>
+                </p:cond>
+              </p:prevCondLst>
+              <p:nextCondLst>
+                <p:cond evt="onNext" delay="0">
+                  <p:tgtEl>
+                    <p:sldTgt/>
+                  </p:tgtEl>
+                </p:cond>
+              </p:nextCondLst>
+            </p:seq>
+          </p:childTnLst>
+        </p:cTn>
+      </p:par>
+    </p:tnLst>
+  </p:timing>
 </p:sld>
 </file>
 
@@ -25741,6 +28779,174 @@
   <p:clrMapOvr>
     <a:masterClrMapping/>
   </p:clrMapOvr>
+  <mc:AlternateContent xmlns:mc="http://schemas.openxmlformats.org/markup-compatibility/2006">
+    <mc:Choice xmlns:p14="http://schemas.microsoft.com/office/powerpoint/2010/main" Requires="p14">
+      <p:transition spd="med" p14:dur="700">
+        <p:fade/>
+      </p:transition>
+    </mc:Choice>
+    <mc:Fallback>
+      <p:transition spd="med">
+        <p:fade/>
+      </p:transition>
+    </mc:Fallback>
+  </mc:AlternateContent>
+  <p:timing>
+    <p:tnLst>
+      <p:par>
+        <p:cTn id="1" dur="indefinite" restart="never" nodeType="tmRoot">
+          <p:childTnLst>
+            <p:seq concurrent="1" nextAc="seek">
+              <p:cTn id="2" dur="indefinite" nodeType="mainSeq">
+                <p:childTnLst>
+                  <p:par>
+                    <p:cTn id="3" fill="hold">
+                      <p:stCondLst>
+                        <p:cond delay="indefinite"/>
+                        <p:cond evt="onBegin" delay="0">
+                          <p:tn val="2"/>
+                        </p:cond>
+                      </p:stCondLst>
+                      <p:childTnLst>
+                        <p:par>
+                          <p:cTn id="4" fill="hold">
+                            <p:stCondLst>
+                              <p:cond delay="0"/>
+                            </p:stCondLst>
+                            <p:childTnLst>
+                              <p:par>
+                                <p:cTn id="5" presetID="10" presetClass="entr" presetSubtype="0" fill="hold" nodeType="afterEffect">
+                                  <p:stCondLst>
+                                    <p:cond delay="0"/>
+                                  </p:stCondLst>
+                                  <p:childTnLst>
+                                    <p:set>
+                                      <p:cBhvr>
+                                        <p:cTn id="6" dur="1" fill="hold">
+                                          <p:stCondLst>
+                                            <p:cond delay="0"/>
+                                          </p:stCondLst>
+                                        </p:cTn>
+                                        <p:tgtEl>
+                                          <p:spTgt spid="4"/>
+                                        </p:tgtEl>
+                                        <p:attrNameLst>
+                                          <p:attrName>style.visibility</p:attrName>
+                                        </p:attrNameLst>
+                                      </p:cBhvr>
+                                      <p:to>
+                                        <p:strVal val="visible"/>
+                                      </p:to>
+                                    </p:set>
+                                    <p:animEffect transition="in" filter="fade">
+                                      <p:cBhvr>
+                                        <p:cTn id="7" dur="500"/>
+                                        <p:tgtEl>
+                                          <p:spTgt spid="4"/>
+                                        </p:tgtEl>
+                                      </p:cBhvr>
+                                    </p:animEffect>
+                                  </p:childTnLst>
+                                </p:cTn>
+                              </p:par>
+                              <p:par>
+                                <p:cTn id="8" presetID="10" presetClass="entr" presetSubtype="0" fill="hold" nodeType="withEffect">
+                                  <p:stCondLst>
+                                    <p:cond delay="300"/>
+                                  </p:stCondLst>
+                                  <p:childTnLst>
+                                    <p:set>
+                                      <p:cBhvr>
+                                        <p:cTn id="9" dur="1" fill="hold">
+                                          <p:stCondLst>
+                                            <p:cond delay="0"/>
+                                          </p:stCondLst>
+                                        </p:cTn>
+                                        <p:tgtEl>
+                                          <p:spTgt spid="29"/>
+                                        </p:tgtEl>
+                                        <p:attrNameLst>
+                                          <p:attrName>style.visibility</p:attrName>
+                                        </p:attrNameLst>
+                                      </p:cBhvr>
+                                      <p:to>
+                                        <p:strVal val="visible"/>
+                                      </p:to>
+                                    </p:set>
+                                    <p:animEffect transition="in" filter="fade">
+                                      <p:cBhvr>
+                                        <p:cTn id="10" dur="500"/>
+                                        <p:tgtEl>
+                                          <p:spTgt spid="29"/>
+                                        </p:tgtEl>
+                                      </p:cBhvr>
+                                    </p:animEffect>
+                                  </p:childTnLst>
+                                </p:cTn>
+                              </p:par>
+                              <p:par>
+                                <p:cTn id="11" presetID="10" presetClass="entr" presetSubtype="0" fill="hold" nodeType="withEffect">
+                                  <p:stCondLst>
+                                    <p:cond delay="600"/>
+                                  </p:stCondLst>
+                                  <p:childTnLst>
+                                    <p:set>
+                                      <p:cBhvr>
+                                        <p:cTn id="12" dur="1" fill="hold">
+                                          <p:stCondLst>
+                                            <p:cond delay="0"/>
+                                          </p:stCondLst>
+                                        </p:cTn>
+                                        <p:tgtEl>
+                                          <p:spTgt spid="30"/>
+                                        </p:tgtEl>
+                                        <p:attrNameLst>
+                                          <p:attrName>style.visibility</p:attrName>
+                                        </p:attrNameLst>
+                                      </p:cBhvr>
+                                      <p:to>
+                                        <p:strVal val="visible"/>
+                                      </p:to>
+                                    </p:set>
+                                    <p:animEffect transition="in" filter="fade">
+                                      <p:cBhvr>
+                                        <p:cTn id="13" dur="500"/>
+                                        <p:tgtEl>
+                                          <p:spTgt spid="30"/>
+                                        </p:tgtEl>
+                                      </p:cBhvr>
+                                    </p:animEffect>
+                                  </p:childTnLst>
+                                </p:cTn>
+                              </p:par>
+                            </p:childTnLst>
+                          </p:cTn>
+                        </p:par>
+                      </p:childTnLst>
+                    </p:cTn>
+                  </p:par>
+                </p:childTnLst>
+              </p:cTn>
+              <p:prevCondLst>
+                <p:cond evt="onPrev" delay="0">
+                  <p:tgtEl>
+                    <p:sldTgt/>
+                  </p:tgtEl>
+                </p:cond>
+              </p:prevCondLst>
+              <p:nextCondLst>
+                <p:cond evt="onNext" delay="0">
+                  <p:tgtEl>
+                    <p:sldTgt/>
+                  </p:tgtEl>
+                </p:cond>
+              </p:nextCondLst>
+            </p:seq>
+          </p:childTnLst>
+        </p:cTn>
+      </p:par>
+    </p:tnLst>
+  </p:timing>
 </p:sld>
 </file>
 
@@ -26469,6 +29675,244 @@
   <p:clrMapOvr>
     <a:masterClrMapping/>
   </p:clrMapOvr>
+  <mc:AlternateContent xmlns:mc="http://schemas.openxmlformats.org/markup-compatibility/2006">
+    <mc:Choice xmlns:p14="http://schemas.microsoft.com/office/powerpoint/2010/main" Requires="p14">
+      <p:transition spd="med" p14:dur="700">
+        <p:fade/>
+      </p:transition>
+    </mc:Choice>
+    <mc:Fallback>
+      <p:transition spd="med">
+        <p:fade/>
+      </p:transition>
+    </mc:Fallback>
+  </mc:AlternateContent>
+  <p:timing>
+    <p:tnLst>
+      <p:par>
+        <p:cTn id="1" dur="indefinite" restart="never" nodeType="tmRoot">
+          <p:childTnLst>
+            <p:seq concurrent="1" nextAc="seek">
+              <p:cTn id="2" dur="indefinite" nodeType="mainSeq">
+                <p:childTnLst>
+                  <p:par>
+                    <p:cTn id="3" fill="hold">
+                      <p:stCondLst>
+                        <p:cond delay="indefinite"/>
+                        <p:cond evt="onBegin" delay="0">
+                          <p:tn val="2"/>
+                        </p:cond>
+                      </p:stCondLst>
+                      <p:childTnLst>
+                        <p:par>
+                          <p:cTn id="4" fill="hold">
+                            <p:stCondLst>
+                              <p:cond delay="0"/>
+                            </p:stCondLst>
+                            <p:childTnLst>
+                              <p:par>
+                                <p:cTn id="5" presetID="10" presetClass="entr" presetSubtype="0" fill="hold" nodeType="afterEffect">
+                                  <p:stCondLst>
+                                    <p:cond delay="0"/>
+                                  </p:stCondLst>
+                                  <p:childTnLst>
+                                    <p:set>
+                                      <p:cBhvr>
+                                        <p:cTn id="6" dur="1" fill="hold">
+                                          <p:stCondLst>
+                                            <p:cond delay="0"/>
+                                          </p:stCondLst>
+                                        </p:cTn>
+                                        <p:tgtEl>
+                                          <p:spTgt spid="3"/>
+                                        </p:tgtEl>
+                                        <p:attrNameLst>
+                                          <p:attrName>style.visibility</p:attrName>
+                                        </p:attrNameLst>
+                                      </p:cBhvr>
+                                      <p:to>
+                                        <p:strVal val="visible"/>
+                                      </p:to>
+                                    </p:set>
+                                    <p:animEffect transition="in" filter="fade">
+                                      <p:cBhvr>
+                                        <p:cTn id="7" dur="500"/>
+                                        <p:tgtEl>
+                                          <p:spTgt spid="3"/>
+                                        </p:tgtEl>
+                                      </p:cBhvr>
+                                    </p:animEffect>
+                                  </p:childTnLst>
+                                </p:cTn>
+                              </p:par>
+                              <p:par>
+                                <p:cTn id="8" presetID="10" presetClass="entr" presetSubtype="0" fill="hold" nodeType="withEffect">
+                                  <p:stCondLst>
+                                    <p:cond delay="300"/>
+                                  </p:stCondLst>
+                                  <p:childTnLst>
+                                    <p:set>
+                                      <p:cBhvr>
+                                        <p:cTn id="9" dur="1" fill="hold">
+                                          <p:stCondLst>
+                                            <p:cond delay="0"/>
+                                          </p:stCondLst>
+                                        </p:cTn>
+                                        <p:tgtEl>
+                                          <p:spTgt spid="4"/>
+                                        </p:tgtEl>
+                                        <p:attrNameLst>
+                                          <p:attrName>style.visibility</p:attrName>
+                                        </p:attrNameLst>
+                                      </p:cBhvr>
+                                      <p:to>
+                                        <p:strVal val="visible"/>
+                                      </p:to>
+                                    </p:set>
+                                    <p:animEffect transition="in" filter="fade">
+                                      <p:cBhvr>
+                                        <p:cTn id="10" dur="500"/>
+                                        <p:tgtEl>
+                                          <p:spTgt spid="4"/>
+                                        </p:tgtEl>
+                                      </p:cBhvr>
+                                    </p:animEffect>
+                                  </p:childTnLst>
+                                </p:cTn>
+                              </p:par>
+                              <p:par>
+                                <p:cTn id="11" presetID="10" presetClass="entr" presetSubtype="0" fill="hold" nodeType="withEffect">
+                                  <p:stCondLst>
+                                    <p:cond delay="600"/>
+                                  </p:stCondLst>
+                                  <p:childTnLst>
+                                    <p:set>
+                                      <p:cBhvr>
+                                        <p:cTn id="12" dur="1" fill="hold">
+                                          <p:stCondLst>
+                                            <p:cond delay="0"/>
+                                          </p:stCondLst>
+                                        </p:cTn>
+                                        <p:tgtEl>
+                                          <p:spTgt spid="5"/>
+                                        </p:tgtEl>
+                                        <p:attrNameLst>
+                                          <p:attrName>style.visibility</p:attrName>
+                                        </p:attrNameLst>
+                                      </p:cBhvr>
+                                      <p:to>
+                                        <p:strVal val="visible"/>
+                                      </p:to>
+                                    </p:set>
+                                    <p:animEffect transition="in" filter="fade">
+                                      <p:cBhvr>
+                                        <p:cTn id="13" dur="500"/>
+                                        <p:tgtEl>
+                                          <p:spTgt spid="5"/>
+                                        </p:tgtEl>
+                                      </p:cBhvr>
+                                    </p:animEffect>
+                                  </p:childTnLst>
+                                </p:cTn>
+                              </p:par>
+                              <p:par>
+                                <p:cTn id="14" presetID="10" presetClass="entr" presetSubtype="0" fill="hold" nodeType="withEffect">
+                                  <p:stCondLst>
+                                    <p:cond delay="900"/>
+                                  </p:stCondLst>
+                                  <p:childTnLst>
+                                    <p:set>
+                                      <p:cBhvr>
+                                        <p:cTn id="15" dur="1" fill="hold">
+                                          <p:stCondLst>
+                                            <p:cond delay="0"/>
+                                          </p:stCondLst>
+                                        </p:cTn>
+                                        <p:tgtEl>
+                                          <p:spTgt spid="6"/>
+                                        </p:tgtEl>
+                                        <p:attrNameLst>
+                                          <p:attrName>style.visibility</p:attrName>
+                                        </p:attrNameLst>
+                                      </p:cBhvr>
+                                      <p:to>
+                                        <p:strVal val="visible"/>
+                                      </p:to>
+                                    </p:set>
+                                    <p:animEffect transition="in" filter="fade">
+                                      <p:cBhvr>
+                                        <p:cTn id="16" dur="500"/>
+                                        <p:tgtEl>
+                                          <p:spTgt spid="6"/>
+                                        </p:tgtEl>
+                                      </p:cBhvr>
+                                    </p:animEffect>
+                                  </p:childTnLst>
+                                </p:cTn>
+                              </p:par>
+                              <p:par>
+                                <p:cTn id="17" presetID="10" presetClass="entr" presetSubtype="0" fill="hold" nodeType="withEffect">
+                                  <p:stCondLst>
+                                    <p:cond delay="1200"/>
+                                  </p:stCondLst>
+                                  <p:childTnLst>
+                                    <p:set>
+                                      <p:cBhvr>
+                                        <p:cTn id="18" dur="1" fill="hold">
+                                          <p:stCondLst>
+                                            <p:cond delay="0"/>
+                                          </p:stCondLst>
+                                        </p:cTn>
+                                        <p:tgtEl>
+                                          <p:spTgt spid="7"/>
+                                        </p:tgtEl>
+                                        <p:attrNameLst>
+                                          <p:attrName>style.visibility</p:attrName>
+                                        </p:attrNameLst>
+                                      </p:cBhvr>
+                                      <p:to>
+                                        <p:strVal val="visible"/>
+                                      </p:to>
+                                    </p:set>
+                                    <p:animEffect transition="in" filter="fade">
+                                      <p:cBhvr>
+                                        <p:cTn id="19" dur="500"/>
+                                        <p:tgtEl>
+                                          <p:spTgt spid="7"/>
+                                        </p:tgtEl>
+                                      </p:cBhvr>
+                                    </p:animEffect>
+                                  </p:childTnLst>
+                                </p:cTn>
+                              </p:par>
+                            </p:childTnLst>
+                          </p:cTn>
+                        </p:par>
+                      </p:childTnLst>
+                    </p:cTn>
+                  </p:par>
+                </p:childTnLst>
+              </p:cTn>
+              <p:prevCondLst>
+                <p:cond evt="onPrev" delay="0">
+                  <p:tgtEl>
+                    <p:sldTgt/>
+                  </p:tgtEl>
+                </p:cond>
+              </p:prevCondLst>
+              <p:nextCondLst>
+                <p:cond evt="onNext" delay="0">
+                  <p:tgtEl>
+                    <p:sldTgt/>
+                  </p:tgtEl>
+                </p:cond>
+              </p:nextCondLst>
+            </p:seq>
+          </p:childTnLst>
+        </p:cTn>
+      </p:par>
+    </p:tnLst>
+  </p:timing>
 </p:sld>
 </file>
 
@@ -27575,6 +31019,174 @@
   <p:clrMapOvr>
     <a:masterClrMapping/>
   </p:clrMapOvr>
+  <mc:AlternateContent xmlns:mc="http://schemas.openxmlformats.org/markup-compatibility/2006">
+    <mc:Choice xmlns:p14="http://schemas.microsoft.com/office/powerpoint/2010/main" Requires="p14">
+      <p:transition spd="med" p14:dur="700">
+        <p:fade/>
+      </p:transition>
+    </mc:Choice>
+    <mc:Fallback>
+      <p:transition spd="med">
+        <p:fade/>
+      </p:transition>
+    </mc:Fallback>
+  </mc:AlternateContent>
+  <p:timing>
+    <p:tnLst>
+      <p:par>
+        <p:cTn id="1" dur="indefinite" restart="never" nodeType="tmRoot">
+          <p:childTnLst>
+            <p:seq concurrent="1" nextAc="seek">
+              <p:cTn id="2" dur="indefinite" nodeType="mainSeq">
+                <p:childTnLst>
+                  <p:par>
+                    <p:cTn id="3" fill="hold">
+                      <p:stCondLst>
+                        <p:cond delay="indefinite"/>
+                        <p:cond evt="onBegin" delay="0">
+                          <p:tn val="2"/>
+                        </p:cond>
+                      </p:stCondLst>
+                      <p:childTnLst>
+                        <p:par>
+                          <p:cTn id="4" fill="hold">
+                            <p:stCondLst>
+                              <p:cond delay="0"/>
+                            </p:stCondLst>
+                            <p:childTnLst>
+                              <p:par>
+                                <p:cTn id="5" presetID="10" presetClass="entr" presetSubtype="0" fill="hold" nodeType="afterEffect">
+                                  <p:stCondLst>
+                                    <p:cond delay="0"/>
+                                  </p:stCondLst>
+                                  <p:childTnLst>
+                                    <p:set>
+                                      <p:cBhvr>
+                                        <p:cTn id="6" dur="1" fill="hold">
+                                          <p:stCondLst>
+                                            <p:cond delay="0"/>
+                                          </p:stCondLst>
+                                        </p:cTn>
+                                        <p:tgtEl>
+                                          <p:spTgt spid="4"/>
+                                        </p:tgtEl>
+                                        <p:attrNameLst>
+                                          <p:attrName>style.visibility</p:attrName>
+                                        </p:attrNameLst>
+                                      </p:cBhvr>
+                                      <p:to>
+                                        <p:strVal val="visible"/>
+                                      </p:to>
+                                    </p:set>
+                                    <p:animEffect transition="in" filter="fade">
+                                      <p:cBhvr>
+                                        <p:cTn id="7" dur="500"/>
+                                        <p:tgtEl>
+                                          <p:spTgt spid="4"/>
+                                        </p:tgtEl>
+                                      </p:cBhvr>
+                                    </p:animEffect>
+                                  </p:childTnLst>
+                                </p:cTn>
+                              </p:par>
+                              <p:par>
+                                <p:cTn id="8" presetID="10" presetClass="entr" presetSubtype="0" fill="hold" nodeType="withEffect">
+                                  <p:stCondLst>
+                                    <p:cond delay="300"/>
+                                  </p:stCondLst>
+                                  <p:childTnLst>
+                                    <p:set>
+                                      <p:cBhvr>
+                                        <p:cTn id="9" dur="1" fill="hold">
+                                          <p:stCondLst>
+                                            <p:cond delay="0"/>
+                                          </p:stCondLst>
+                                        </p:cTn>
+                                        <p:tgtEl>
+                                          <p:spTgt spid="30"/>
+                                        </p:tgtEl>
+                                        <p:attrNameLst>
+                                          <p:attrName>style.visibility</p:attrName>
+                                        </p:attrNameLst>
+                                      </p:cBhvr>
+                                      <p:to>
+                                        <p:strVal val="visible"/>
+                                      </p:to>
+                                    </p:set>
+                                    <p:animEffect transition="in" filter="fade">
+                                      <p:cBhvr>
+                                        <p:cTn id="10" dur="500"/>
+                                        <p:tgtEl>
+                                          <p:spTgt spid="30"/>
+                                        </p:tgtEl>
+                                      </p:cBhvr>
+                                    </p:animEffect>
+                                  </p:childTnLst>
+                                </p:cTn>
+                              </p:par>
+                              <p:par>
+                                <p:cTn id="11" presetID="10" presetClass="entr" presetSubtype="0" fill="hold" nodeType="withEffect">
+                                  <p:stCondLst>
+                                    <p:cond delay="600"/>
+                                  </p:stCondLst>
+                                  <p:childTnLst>
+                                    <p:set>
+                                      <p:cBhvr>
+                                        <p:cTn id="12" dur="1" fill="hold">
+                                          <p:stCondLst>
+                                            <p:cond delay="0"/>
+                                          </p:stCondLst>
+                                        </p:cTn>
+                                        <p:tgtEl>
+                                          <p:spTgt spid="31"/>
+                                        </p:tgtEl>
+                                        <p:attrNameLst>
+                                          <p:attrName>style.visibility</p:attrName>
+                                        </p:attrNameLst>
+                                      </p:cBhvr>
+                                      <p:to>
+                                        <p:strVal val="visible"/>
+                                      </p:to>
+                                    </p:set>
+                                    <p:animEffect transition="in" filter="fade">
+                                      <p:cBhvr>
+                                        <p:cTn id="13" dur="500"/>
+                                        <p:tgtEl>
+                                          <p:spTgt spid="31"/>
+                                        </p:tgtEl>
+                                      </p:cBhvr>
+                                    </p:animEffect>
+                                  </p:childTnLst>
+                                </p:cTn>
+                              </p:par>
+                            </p:childTnLst>
+                          </p:cTn>
+                        </p:par>
+                      </p:childTnLst>
+                    </p:cTn>
+                  </p:par>
+                </p:childTnLst>
+              </p:cTn>
+              <p:prevCondLst>
+                <p:cond evt="onPrev" delay="0">
+                  <p:tgtEl>
+                    <p:sldTgt/>
+                  </p:tgtEl>
+                </p:cond>
+              </p:prevCondLst>
+              <p:nextCondLst>
+                <p:cond evt="onNext" delay="0">
+                  <p:tgtEl>
+                    <p:sldTgt/>
+                  </p:tgtEl>
+                </p:cond>
+              </p:nextCondLst>
+            </p:seq>
+          </p:childTnLst>
+        </p:cTn>
+      </p:par>
+    </p:tnLst>
+  </p:timing>
 </p:sld>
 </file>
 
@@ -30177,6 +33789,174 @@
   <p:clrMapOvr>
     <a:masterClrMapping/>
   </p:clrMapOvr>
+  <mc:AlternateContent xmlns:mc="http://schemas.openxmlformats.org/markup-compatibility/2006">
+    <mc:Choice xmlns:p14="http://schemas.microsoft.com/office/powerpoint/2010/main" Requires="p14">
+      <p:transition spd="med" p14:dur="700">
+        <p:fade/>
+      </p:transition>
+    </mc:Choice>
+    <mc:Fallback>
+      <p:transition spd="med">
+        <p:fade/>
+      </p:transition>
+    </mc:Fallback>
+  </mc:AlternateContent>
+  <p:timing>
+    <p:tnLst>
+      <p:par>
+        <p:cTn id="1" dur="indefinite" restart="never" nodeType="tmRoot">
+          <p:childTnLst>
+            <p:seq concurrent="1" nextAc="seek">
+              <p:cTn id="2" dur="indefinite" nodeType="mainSeq">
+                <p:childTnLst>
+                  <p:par>
+                    <p:cTn id="3" fill="hold">
+                      <p:stCondLst>
+                        <p:cond delay="indefinite"/>
+                        <p:cond evt="onBegin" delay="0">
+                          <p:tn val="2"/>
+                        </p:cond>
+                      </p:stCondLst>
+                      <p:childTnLst>
+                        <p:par>
+                          <p:cTn id="4" fill="hold">
+                            <p:stCondLst>
+                              <p:cond delay="0"/>
+                            </p:stCondLst>
+                            <p:childTnLst>
+                              <p:par>
+                                <p:cTn id="5" presetID="10" presetClass="entr" presetSubtype="0" fill="hold" nodeType="afterEffect">
+                                  <p:stCondLst>
+                                    <p:cond delay="0"/>
+                                  </p:stCondLst>
+                                  <p:childTnLst>
+                                    <p:set>
+                                      <p:cBhvr>
+                                        <p:cTn id="6" dur="1" fill="hold">
+                                          <p:stCondLst>
+                                            <p:cond delay="0"/>
+                                          </p:stCondLst>
+                                        </p:cTn>
+                                        <p:tgtEl>
+                                          <p:spTgt spid="4"/>
+                                        </p:tgtEl>
+                                        <p:attrNameLst>
+                                          <p:attrName>style.visibility</p:attrName>
+                                        </p:attrNameLst>
+                                      </p:cBhvr>
+                                      <p:to>
+                                        <p:strVal val="visible"/>
+                                      </p:to>
+                                    </p:set>
+                                    <p:animEffect transition="in" filter="fade">
+                                      <p:cBhvr>
+                                        <p:cTn id="7" dur="500"/>
+                                        <p:tgtEl>
+                                          <p:spTgt spid="4"/>
+                                        </p:tgtEl>
+                                      </p:cBhvr>
+                                    </p:animEffect>
+                                  </p:childTnLst>
+                                </p:cTn>
+                              </p:par>
+                              <p:par>
+                                <p:cTn id="8" presetID="10" presetClass="entr" presetSubtype="0" fill="hold" nodeType="withEffect">
+                                  <p:stCondLst>
+                                    <p:cond delay="300"/>
+                                  </p:stCondLst>
+                                  <p:childTnLst>
+                                    <p:set>
+                                      <p:cBhvr>
+                                        <p:cTn id="9" dur="1" fill="hold">
+                                          <p:stCondLst>
+                                            <p:cond delay="0"/>
+                                          </p:stCondLst>
+                                        </p:cTn>
+                                        <p:tgtEl>
+                                          <p:spTgt spid="90"/>
+                                        </p:tgtEl>
+                                        <p:attrNameLst>
+                                          <p:attrName>style.visibility</p:attrName>
+                                        </p:attrNameLst>
+                                      </p:cBhvr>
+                                      <p:to>
+                                        <p:strVal val="visible"/>
+                                      </p:to>
+                                    </p:set>
+                                    <p:animEffect transition="in" filter="fade">
+                                      <p:cBhvr>
+                                        <p:cTn id="10" dur="500"/>
+                                        <p:tgtEl>
+                                          <p:spTgt spid="90"/>
+                                        </p:tgtEl>
+                                      </p:cBhvr>
+                                    </p:animEffect>
+                                  </p:childTnLst>
+                                </p:cTn>
+                              </p:par>
+                              <p:par>
+                                <p:cTn id="11" presetID="10" presetClass="entr" presetSubtype="0" fill="hold" nodeType="withEffect">
+                                  <p:stCondLst>
+                                    <p:cond delay="600"/>
+                                  </p:stCondLst>
+                                  <p:childTnLst>
+                                    <p:set>
+                                      <p:cBhvr>
+                                        <p:cTn id="12" dur="1" fill="hold">
+                                          <p:stCondLst>
+                                            <p:cond delay="0"/>
+                                          </p:stCondLst>
+                                        </p:cTn>
+                                        <p:tgtEl>
+                                          <p:spTgt spid="91"/>
+                                        </p:tgtEl>
+                                        <p:attrNameLst>
+                                          <p:attrName>style.visibility</p:attrName>
+                                        </p:attrNameLst>
+                                      </p:cBhvr>
+                                      <p:to>
+                                        <p:strVal val="visible"/>
+                                      </p:to>
+                                    </p:set>
+                                    <p:animEffect transition="in" filter="fade">
+                                      <p:cBhvr>
+                                        <p:cTn id="13" dur="500"/>
+                                        <p:tgtEl>
+                                          <p:spTgt spid="91"/>
+                                        </p:tgtEl>
+                                      </p:cBhvr>
+                                    </p:animEffect>
+                                  </p:childTnLst>
+                                </p:cTn>
+                              </p:par>
+                            </p:childTnLst>
+                          </p:cTn>
+                        </p:par>
+                      </p:childTnLst>
+                    </p:cTn>
+                  </p:par>
+                </p:childTnLst>
+              </p:cTn>
+              <p:prevCondLst>
+                <p:cond evt="onPrev" delay="0">
+                  <p:tgtEl>
+                    <p:sldTgt/>
+                  </p:tgtEl>
+                </p:cond>
+              </p:prevCondLst>
+              <p:nextCondLst>
+                <p:cond evt="onNext" delay="0">
+                  <p:tgtEl>
+                    <p:sldTgt/>
+                  </p:tgtEl>
+                </p:cond>
+              </p:nextCondLst>
+            </p:seq>
+          </p:childTnLst>
+        </p:cTn>
+      </p:par>
+    </p:tnLst>
+  </p:timing>
 </p:sld>
 </file>
 
@@ -31573,6 +35353,174 @@
   <p:clrMapOvr>
     <a:masterClrMapping/>
   </p:clrMapOvr>
+  <mc:AlternateContent xmlns:mc="http://schemas.openxmlformats.org/markup-compatibility/2006">
+    <mc:Choice xmlns:p14="http://schemas.microsoft.com/office/powerpoint/2010/main" Requires="p14">
+      <p:transition spd="med" p14:dur="700">
+        <p:fade/>
+      </p:transition>
+    </mc:Choice>
+    <mc:Fallback>
+      <p:transition spd="med">
+        <p:fade/>
+      </p:transition>
+    </mc:Fallback>
+  </mc:AlternateContent>
+  <p:timing>
+    <p:tnLst>
+      <p:par>
+        <p:cTn id="1" dur="indefinite" restart="never" nodeType="tmRoot">
+          <p:childTnLst>
+            <p:seq concurrent="1" nextAc="seek">
+              <p:cTn id="2" dur="indefinite" nodeType="mainSeq">
+                <p:childTnLst>
+                  <p:par>
+                    <p:cTn id="3" fill="hold">
+                      <p:stCondLst>
+                        <p:cond delay="indefinite"/>
+                        <p:cond evt="onBegin" delay="0">
+                          <p:tn val="2"/>
+                        </p:cond>
+                      </p:stCondLst>
+                      <p:childTnLst>
+                        <p:par>
+                          <p:cTn id="4" fill="hold">
+                            <p:stCondLst>
+                              <p:cond delay="0"/>
+                            </p:stCondLst>
+                            <p:childTnLst>
+                              <p:par>
+                                <p:cTn id="5" presetID="10" presetClass="entr" presetSubtype="0" fill="hold" nodeType="afterEffect">
+                                  <p:stCondLst>
+                                    <p:cond delay="0"/>
+                                  </p:stCondLst>
+                                  <p:childTnLst>
+                                    <p:set>
+                                      <p:cBhvr>
+                                        <p:cTn id="6" dur="1" fill="hold">
+                                          <p:stCondLst>
+                                            <p:cond delay="0"/>
+                                          </p:stCondLst>
+                                        </p:cTn>
+                                        <p:tgtEl>
+                                          <p:spTgt spid="4"/>
+                                        </p:tgtEl>
+                                        <p:attrNameLst>
+                                          <p:attrName>style.visibility</p:attrName>
+                                        </p:attrNameLst>
+                                      </p:cBhvr>
+                                      <p:to>
+                                        <p:strVal val="visible"/>
+                                      </p:to>
+                                    </p:set>
+                                    <p:animEffect transition="in" filter="fade">
+                                      <p:cBhvr>
+                                        <p:cTn id="7" dur="500"/>
+                                        <p:tgtEl>
+                                          <p:spTgt spid="4"/>
+                                        </p:tgtEl>
+                                      </p:cBhvr>
+                                    </p:animEffect>
+                                  </p:childTnLst>
+                                </p:cTn>
+                              </p:par>
+                              <p:par>
+                                <p:cTn id="8" presetID="10" presetClass="entr" presetSubtype="0" fill="hold" nodeType="withEffect">
+                                  <p:stCondLst>
+                                    <p:cond delay="300"/>
+                                  </p:stCondLst>
+                                  <p:childTnLst>
+                                    <p:set>
+                                      <p:cBhvr>
+                                        <p:cTn id="9" dur="1" fill="hold">
+                                          <p:stCondLst>
+                                            <p:cond delay="0"/>
+                                          </p:stCondLst>
+                                        </p:cTn>
+                                        <p:tgtEl>
+                                          <p:spTgt spid="44"/>
+                                        </p:tgtEl>
+                                        <p:attrNameLst>
+                                          <p:attrName>style.visibility</p:attrName>
+                                        </p:attrNameLst>
+                                      </p:cBhvr>
+                                      <p:to>
+                                        <p:strVal val="visible"/>
+                                      </p:to>
+                                    </p:set>
+                                    <p:animEffect transition="in" filter="fade">
+                                      <p:cBhvr>
+                                        <p:cTn id="10" dur="500"/>
+                                        <p:tgtEl>
+                                          <p:spTgt spid="44"/>
+                                        </p:tgtEl>
+                                      </p:cBhvr>
+                                    </p:animEffect>
+                                  </p:childTnLst>
+                                </p:cTn>
+                              </p:par>
+                              <p:par>
+                                <p:cTn id="11" presetID="10" presetClass="entr" presetSubtype="0" fill="hold" nodeType="withEffect">
+                                  <p:stCondLst>
+                                    <p:cond delay="600"/>
+                                  </p:stCondLst>
+                                  <p:childTnLst>
+                                    <p:set>
+                                      <p:cBhvr>
+                                        <p:cTn id="12" dur="1" fill="hold">
+                                          <p:stCondLst>
+                                            <p:cond delay="0"/>
+                                          </p:stCondLst>
+                                        </p:cTn>
+                                        <p:tgtEl>
+                                          <p:spTgt spid="45"/>
+                                        </p:tgtEl>
+                                        <p:attrNameLst>
+                                          <p:attrName>style.visibility</p:attrName>
+                                        </p:attrNameLst>
+                                      </p:cBhvr>
+                                      <p:to>
+                                        <p:strVal val="visible"/>
+                                      </p:to>
+                                    </p:set>
+                                    <p:animEffect transition="in" filter="fade">
+                                      <p:cBhvr>
+                                        <p:cTn id="13" dur="500"/>
+                                        <p:tgtEl>
+                                          <p:spTgt spid="45"/>
+                                        </p:tgtEl>
+                                      </p:cBhvr>
+                                    </p:animEffect>
+                                  </p:childTnLst>
+                                </p:cTn>
+                              </p:par>
+                            </p:childTnLst>
+                          </p:cTn>
+                        </p:par>
+                      </p:childTnLst>
+                    </p:cTn>
+                  </p:par>
+                </p:childTnLst>
+              </p:cTn>
+              <p:prevCondLst>
+                <p:cond evt="onPrev" delay="0">
+                  <p:tgtEl>
+                    <p:sldTgt/>
+                  </p:tgtEl>
+                </p:cond>
+              </p:prevCondLst>
+              <p:nextCondLst>
+                <p:cond evt="onNext" delay="0">
+                  <p:tgtEl>
+                    <p:sldTgt/>
+                  </p:tgtEl>
+                </p:cond>
+              </p:nextCondLst>
+            </p:seq>
+          </p:childTnLst>
+        </p:cTn>
+      </p:par>
+    </p:tnLst>
+  </p:timing>
 </p:sld>
 </file>
 
@@ -33753,6 +37701,209 @@
   <p:clrMapOvr>
     <a:masterClrMapping/>
   </p:clrMapOvr>
+  <mc:AlternateContent xmlns:mc="http://schemas.openxmlformats.org/markup-compatibility/2006">
+    <mc:Choice xmlns:p14="http://schemas.microsoft.com/office/powerpoint/2010/main" Requires="p14">
+      <p:transition spd="med" p14:dur="700">
+        <p:fade/>
+      </p:transition>
+    </mc:Choice>
+    <mc:Fallback>
+      <p:transition spd="med">
+        <p:fade/>
+      </p:transition>
+    </mc:Fallback>
+  </mc:AlternateContent>
+  <p:timing>
+    <p:tnLst>
+      <p:par>
+        <p:cTn id="1" dur="indefinite" restart="never" nodeType="tmRoot">
+          <p:childTnLst>
+            <p:seq concurrent="1" nextAc="seek">
+              <p:cTn id="2" dur="indefinite" nodeType="mainSeq">
+                <p:childTnLst>
+                  <p:par>
+                    <p:cTn id="3" fill="hold">
+                      <p:stCondLst>
+                        <p:cond delay="indefinite"/>
+                        <p:cond evt="onBegin" delay="0">
+                          <p:tn val="2"/>
+                        </p:cond>
+                      </p:stCondLst>
+                      <p:childTnLst>
+                        <p:par>
+                          <p:cTn id="4" fill="hold">
+                            <p:stCondLst>
+                              <p:cond delay="0"/>
+                            </p:stCondLst>
+                            <p:childTnLst>
+                              <p:par>
+                                <p:cTn id="5" presetID="10" presetClass="entr" presetSubtype="0" fill="hold" nodeType="afterEffect">
+                                  <p:stCondLst>
+                                    <p:cond delay="0"/>
+                                  </p:stCondLst>
+                                  <p:childTnLst>
+                                    <p:set>
+                                      <p:cBhvr>
+                                        <p:cTn id="6" dur="1" fill="hold">
+                                          <p:stCondLst>
+                                            <p:cond delay="0"/>
+                                          </p:stCondLst>
+                                        </p:cTn>
+                                        <p:tgtEl>
+                                          <p:spTgt spid="4"/>
+                                        </p:tgtEl>
+                                        <p:attrNameLst>
+                                          <p:attrName>style.visibility</p:attrName>
+                                        </p:attrNameLst>
+                                      </p:cBhvr>
+                                      <p:to>
+                                        <p:strVal val="visible"/>
+                                      </p:to>
+                                    </p:set>
+                                    <p:animEffect transition="in" filter="fade">
+                                      <p:cBhvr>
+                                        <p:cTn id="7" dur="500"/>
+                                        <p:tgtEl>
+                                          <p:spTgt spid="4"/>
+                                        </p:tgtEl>
+                                      </p:cBhvr>
+                                    </p:animEffect>
+                                  </p:childTnLst>
+                                </p:cTn>
+                              </p:par>
+                              <p:par>
+                                <p:cTn id="8" presetID="10" presetClass="entr" presetSubtype="0" fill="hold" nodeType="withEffect">
+                                  <p:stCondLst>
+                                    <p:cond delay="300"/>
+                                  </p:stCondLst>
+                                  <p:childTnLst>
+                                    <p:set>
+                                      <p:cBhvr>
+                                        <p:cTn id="9" dur="1" fill="hold">
+                                          <p:stCondLst>
+                                            <p:cond delay="0"/>
+                                          </p:stCondLst>
+                                        </p:cTn>
+                                        <p:tgtEl>
+                                          <p:spTgt spid="73"/>
+                                        </p:tgtEl>
+                                        <p:attrNameLst>
+                                          <p:attrName>style.visibility</p:attrName>
+                                        </p:attrNameLst>
+                                      </p:cBhvr>
+                                      <p:to>
+                                        <p:strVal val="visible"/>
+                                      </p:to>
+                                    </p:set>
+                                    <p:animEffect transition="in" filter="fade">
+                                      <p:cBhvr>
+                                        <p:cTn id="10" dur="500"/>
+                                        <p:tgtEl>
+                                          <p:spTgt spid="73"/>
+                                        </p:tgtEl>
+                                      </p:cBhvr>
+                                    </p:animEffect>
+                                  </p:childTnLst>
+                                </p:cTn>
+                              </p:par>
+                              <p:par>
+                                <p:cTn id="11" presetID="10" presetClass="entr" presetSubtype="0" fill="hold" nodeType="withEffect">
+                                  <p:stCondLst>
+                                    <p:cond delay="600"/>
+                                  </p:stCondLst>
+                                  <p:childTnLst>
+                                    <p:set>
+                                      <p:cBhvr>
+                                        <p:cTn id="12" dur="1" fill="hold">
+                                          <p:stCondLst>
+                                            <p:cond delay="0"/>
+                                          </p:stCondLst>
+                                        </p:cTn>
+                                        <p:tgtEl>
+                                          <p:spTgt spid="74"/>
+                                        </p:tgtEl>
+                                        <p:attrNameLst>
+                                          <p:attrName>style.visibility</p:attrName>
+                                        </p:attrNameLst>
+                                      </p:cBhvr>
+                                      <p:to>
+                                        <p:strVal val="visible"/>
+                                      </p:to>
+                                    </p:set>
+                                    <p:animEffect transition="in" filter="fade">
+                                      <p:cBhvr>
+                                        <p:cTn id="13" dur="500"/>
+                                        <p:tgtEl>
+                                          <p:spTgt spid="74"/>
+                                        </p:tgtEl>
+                                      </p:cBhvr>
+                                    </p:animEffect>
+                                  </p:childTnLst>
+                                </p:cTn>
+                              </p:par>
+                              <p:par>
+                                <p:cTn id="14" presetID="10" presetClass="entr" presetSubtype="0" fill="hold" nodeType="withEffect">
+                                  <p:stCondLst>
+                                    <p:cond delay="900"/>
+                                  </p:stCondLst>
+                                  <p:childTnLst>
+                                    <p:set>
+                                      <p:cBhvr>
+                                        <p:cTn id="15" dur="1" fill="hold">
+                                          <p:stCondLst>
+                                            <p:cond delay="0"/>
+                                          </p:stCondLst>
+                                        </p:cTn>
+                                        <p:tgtEl>
+                                          <p:spTgt spid="75"/>
+                                        </p:tgtEl>
+                                        <p:attrNameLst>
+                                          <p:attrName>style.visibility</p:attrName>
+                                        </p:attrNameLst>
+                                      </p:cBhvr>
+                                      <p:to>
+                                        <p:strVal val="visible"/>
+                                      </p:to>
+                                    </p:set>
+                                    <p:animEffect transition="in" filter="fade">
+                                      <p:cBhvr>
+                                        <p:cTn id="16" dur="500"/>
+                                        <p:tgtEl>
+                                          <p:spTgt spid="75"/>
+                                        </p:tgtEl>
+                                      </p:cBhvr>
+                                    </p:animEffect>
+                                  </p:childTnLst>
+                                </p:cTn>
+                              </p:par>
+                            </p:childTnLst>
+                          </p:cTn>
+                        </p:par>
+                      </p:childTnLst>
+                    </p:cTn>
+                  </p:par>
+                </p:childTnLst>
+              </p:cTn>
+              <p:prevCondLst>
+                <p:cond evt="onPrev" delay="0">
+                  <p:tgtEl>
+                    <p:sldTgt/>
+                  </p:tgtEl>
+                </p:cond>
+              </p:prevCondLst>
+              <p:nextCondLst>
+                <p:cond evt="onNext" delay="0">
+                  <p:tgtEl>
+                    <p:sldTgt/>
+                  </p:tgtEl>
+                </p:cond>
+              </p:nextCondLst>
+            </p:seq>
+          </p:childTnLst>
+        </p:cTn>
+      </p:par>
+    </p:tnLst>
+  </p:timing>
 </p:sld>
 </file>
 
@@ -35308,6 +39459,174 @@
   <p:clrMapOvr>
     <a:masterClrMapping/>
   </p:clrMapOvr>
+  <mc:AlternateContent xmlns:mc="http://schemas.openxmlformats.org/markup-compatibility/2006">
+    <mc:Choice xmlns:p14="http://schemas.microsoft.com/office/powerpoint/2010/main" Requires="p14">
+      <p:transition spd="med" p14:dur="700">
+        <p:fade/>
+      </p:transition>
+    </mc:Choice>
+    <mc:Fallback>
+      <p:transition spd="med">
+        <p:fade/>
+      </p:transition>
+    </mc:Fallback>
+  </mc:AlternateContent>
+  <p:timing>
+    <p:tnLst>
+      <p:par>
+        <p:cTn id="1" dur="indefinite" restart="never" nodeType="tmRoot">
+          <p:childTnLst>
+            <p:seq concurrent="1" nextAc="seek">
+              <p:cTn id="2" dur="indefinite" nodeType="mainSeq">
+                <p:childTnLst>
+                  <p:par>
+                    <p:cTn id="3" fill="hold">
+                      <p:stCondLst>
+                        <p:cond delay="indefinite"/>
+                        <p:cond evt="onBegin" delay="0">
+                          <p:tn val="2"/>
+                        </p:cond>
+                      </p:stCondLst>
+                      <p:childTnLst>
+                        <p:par>
+                          <p:cTn id="4" fill="hold">
+                            <p:stCondLst>
+                              <p:cond delay="0"/>
+                            </p:stCondLst>
+                            <p:childTnLst>
+                              <p:par>
+                                <p:cTn id="5" presetID="10" presetClass="entr" presetSubtype="0" fill="hold" nodeType="afterEffect">
+                                  <p:stCondLst>
+                                    <p:cond delay="0"/>
+                                  </p:stCondLst>
+                                  <p:childTnLst>
+                                    <p:set>
+                                      <p:cBhvr>
+                                        <p:cTn id="6" dur="1" fill="hold">
+                                          <p:stCondLst>
+                                            <p:cond delay="0"/>
+                                          </p:stCondLst>
+                                        </p:cTn>
+                                        <p:tgtEl>
+                                          <p:spTgt spid="4"/>
+                                        </p:tgtEl>
+                                        <p:attrNameLst>
+                                          <p:attrName>style.visibility</p:attrName>
+                                        </p:attrNameLst>
+                                      </p:cBhvr>
+                                      <p:to>
+                                        <p:strVal val="visible"/>
+                                      </p:to>
+                                    </p:set>
+                                    <p:animEffect transition="in" filter="fade">
+                                      <p:cBhvr>
+                                        <p:cTn id="7" dur="500"/>
+                                        <p:tgtEl>
+                                          <p:spTgt spid="4"/>
+                                        </p:tgtEl>
+                                      </p:cBhvr>
+                                    </p:animEffect>
+                                  </p:childTnLst>
+                                </p:cTn>
+                              </p:par>
+                              <p:par>
+                                <p:cTn id="8" presetID="10" presetClass="entr" presetSubtype="0" fill="hold" nodeType="withEffect">
+                                  <p:stCondLst>
+                                    <p:cond delay="300"/>
+                                  </p:stCondLst>
+                                  <p:childTnLst>
+                                    <p:set>
+                                      <p:cBhvr>
+                                        <p:cTn id="9" dur="1" fill="hold">
+                                          <p:stCondLst>
+                                            <p:cond delay="0"/>
+                                          </p:stCondLst>
+                                        </p:cTn>
+                                        <p:tgtEl>
+                                          <p:spTgt spid="48"/>
+                                        </p:tgtEl>
+                                        <p:attrNameLst>
+                                          <p:attrName>style.visibility</p:attrName>
+                                        </p:attrNameLst>
+                                      </p:cBhvr>
+                                      <p:to>
+                                        <p:strVal val="visible"/>
+                                      </p:to>
+                                    </p:set>
+                                    <p:animEffect transition="in" filter="fade">
+                                      <p:cBhvr>
+                                        <p:cTn id="10" dur="500"/>
+                                        <p:tgtEl>
+                                          <p:spTgt spid="48"/>
+                                        </p:tgtEl>
+                                      </p:cBhvr>
+                                    </p:animEffect>
+                                  </p:childTnLst>
+                                </p:cTn>
+                              </p:par>
+                              <p:par>
+                                <p:cTn id="11" presetID="10" presetClass="entr" presetSubtype="0" fill="hold" nodeType="withEffect">
+                                  <p:stCondLst>
+                                    <p:cond delay="600"/>
+                                  </p:stCondLst>
+                                  <p:childTnLst>
+                                    <p:set>
+                                      <p:cBhvr>
+                                        <p:cTn id="12" dur="1" fill="hold">
+                                          <p:stCondLst>
+                                            <p:cond delay="0"/>
+                                          </p:stCondLst>
+                                        </p:cTn>
+                                        <p:tgtEl>
+                                          <p:spTgt spid="49"/>
+                                        </p:tgtEl>
+                                        <p:attrNameLst>
+                                          <p:attrName>style.visibility</p:attrName>
+                                        </p:attrNameLst>
+                                      </p:cBhvr>
+                                      <p:to>
+                                        <p:strVal val="visible"/>
+                                      </p:to>
+                                    </p:set>
+                                    <p:animEffect transition="in" filter="fade">
+                                      <p:cBhvr>
+                                        <p:cTn id="13" dur="500"/>
+                                        <p:tgtEl>
+                                          <p:spTgt spid="49"/>
+                                        </p:tgtEl>
+                                      </p:cBhvr>
+                                    </p:animEffect>
+                                  </p:childTnLst>
+                                </p:cTn>
+                              </p:par>
+                            </p:childTnLst>
+                          </p:cTn>
+                        </p:par>
+                      </p:childTnLst>
+                    </p:cTn>
+                  </p:par>
+                </p:childTnLst>
+              </p:cTn>
+              <p:prevCondLst>
+                <p:cond evt="onPrev" delay="0">
+                  <p:tgtEl>
+                    <p:sldTgt/>
+                  </p:tgtEl>
+                </p:cond>
+              </p:prevCondLst>
+              <p:nextCondLst>
+                <p:cond evt="onNext" delay="0">
+                  <p:tgtEl>
+                    <p:sldTgt/>
+                  </p:tgtEl>
+                </p:cond>
+              </p:nextCondLst>
+            </p:seq>
+          </p:childTnLst>
+        </p:cTn>
+      </p:par>
+    </p:tnLst>
+  </p:timing>
 </p:sld>
 </file>
 
@@ -35891,6 +40210,174 @@
   <p:clrMapOvr>
     <a:masterClrMapping/>
   </p:clrMapOvr>
+  <mc:AlternateContent xmlns:mc="http://schemas.openxmlformats.org/markup-compatibility/2006">
+    <mc:Choice xmlns:p14="http://schemas.microsoft.com/office/powerpoint/2010/main" Requires="p14">
+      <p:transition spd="med" p14:dur="700">
+        <p:fade/>
+      </p:transition>
+    </mc:Choice>
+    <mc:Fallback>
+      <p:transition spd="med">
+        <p:fade/>
+      </p:transition>
+    </mc:Fallback>
+  </mc:AlternateContent>
+  <p:timing>
+    <p:tnLst>
+      <p:par>
+        <p:cTn id="1" dur="indefinite" restart="never" nodeType="tmRoot">
+          <p:childTnLst>
+            <p:seq concurrent="1" nextAc="seek">
+              <p:cTn id="2" dur="indefinite" nodeType="mainSeq">
+                <p:childTnLst>
+                  <p:par>
+                    <p:cTn id="3" fill="hold">
+                      <p:stCondLst>
+                        <p:cond delay="indefinite"/>
+                        <p:cond evt="onBegin" delay="0">
+                          <p:tn val="2"/>
+                        </p:cond>
+                      </p:stCondLst>
+                      <p:childTnLst>
+                        <p:par>
+                          <p:cTn id="4" fill="hold">
+                            <p:stCondLst>
+                              <p:cond delay="0"/>
+                            </p:stCondLst>
+                            <p:childTnLst>
+                              <p:par>
+                                <p:cTn id="5" presetID="10" presetClass="entr" presetSubtype="0" fill="hold" nodeType="afterEffect">
+                                  <p:stCondLst>
+                                    <p:cond delay="0"/>
+                                  </p:stCondLst>
+                                  <p:childTnLst>
+                                    <p:set>
+                                      <p:cBhvr>
+                                        <p:cTn id="6" dur="1" fill="hold">
+                                          <p:stCondLst>
+                                            <p:cond delay="0"/>
+                                          </p:stCondLst>
+                                        </p:cTn>
+                                        <p:tgtEl>
+                                          <p:spTgt spid="4"/>
+                                        </p:tgtEl>
+                                        <p:attrNameLst>
+                                          <p:attrName>style.visibility</p:attrName>
+                                        </p:attrNameLst>
+                                      </p:cBhvr>
+                                      <p:to>
+                                        <p:strVal val="visible"/>
+                                      </p:to>
+                                    </p:set>
+                                    <p:animEffect transition="in" filter="fade">
+                                      <p:cBhvr>
+                                        <p:cTn id="7" dur="500"/>
+                                        <p:tgtEl>
+                                          <p:spTgt spid="4"/>
+                                        </p:tgtEl>
+                                      </p:cBhvr>
+                                    </p:animEffect>
+                                  </p:childTnLst>
+                                </p:cTn>
+                              </p:par>
+                              <p:par>
+                                <p:cTn id="8" presetID="10" presetClass="entr" presetSubtype="0" fill="hold" nodeType="withEffect">
+                                  <p:stCondLst>
+                                    <p:cond delay="300"/>
+                                  </p:stCondLst>
+                                  <p:childTnLst>
+                                    <p:set>
+                                      <p:cBhvr>
+                                        <p:cTn id="9" dur="1" fill="hold">
+                                          <p:stCondLst>
+                                            <p:cond delay="0"/>
+                                          </p:stCondLst>
+                                        </p:cTn>
+                                        <p:tgtEl>
+                                          <p:spTgt spid="15"/>
+                                        </p:tgtEl>
+                                        <p:attrNameLst>
+                                          <p:attrName>style.visibility</p:attrName>
+                                        </p:attrNameLst>
+                                      </p:cBhvr>
+                                      <p:to>
+                                        <p:strVal val="visible"/>
+                                      </p:to>
+                                    </p:set>
+                                    <p:animEffect transition="in" filter="fade">
+                                      <p:cBhvr>
+                                        <p:cTn id="10" dur="500"/>
+                                        <p:tgtEl>
+                                          <p:spTgt spid="15"/>
+                                        </p:tgtEl>
+                                      </p:cBhvr>
+                                    </p:animEffect>
+                                  </p:childTnLst>
+                                </p:cTn>
+                              </p:par>
+                              <p:par>
+                                <p:cTn id="11" presetID="10" presetClass="entr" presetSubtype="0" fill="hold" nodeType="withEffect">
+                                  <p:stCondLst>
+                                    <p:cond delay="600"/>
+                                  </p:stCondLst>
+                                  <p:childTnLst>
+                                    <p:set>
+                                      <p:cBhvr>
+                                        <p:cTn id="12" dur="1" fill="hold">
+                                          <p:stCondLst>
+                                            <p:cond delay="0"/>
+                                          </p:stCondLst>
+                                        </p:cTn>
+                                        <p:tgtEl>
+                                          <p:spTgt spid="16"/>
+                                        </p:tgtEl>
+                                        <p:attrNameLst>
+                                          <p:attrName>style.visibility</p:attrName>
+                                        </p:attrNameLst>
+                                      </p:cBhvr>
+                                      <p:to>
+                                        <p:strVal val="visible"/>
+                                      </p:to>
+                                    </p:set>
+                                    <p:animEffect transition="in" filter="fade">
+                                      <p:cBhvr>
+                                        <p:cTn id="13" dur="500"/>
+                                        <p:tgtEl>
+                                          <p:spTgt spid="16"/>
+                                        </p:tgtEl>
+                                      </p:cBhvr>
+                                    </p:animEffect>
+                                  </p:childTnLst>
+                                </p:cTn>
+                              </p:par>
+                            </p:childTnLst>
+                          </p:cTn>
+                        </p:par>
+                      </p:childTnLst>
+                    </p:cTn>
+                  </p:par>
+                </p:childTnLst>
+              </p:cTn>
+              <p:prevCondLst>
+                <p:cond evt="onPrev" delay="0">
+                  <p:tgtEl>
+                    <p:sldTgt/>
+                  </p:tgtEl>
+                </p:cond>
+              </p:prevCondLst>
+              <p:nextCondLst>
+                <p:cond evt="onNext" delay="0">
+                  <p:tgtEl>
+                    <p:sldTgt/>
+                  </p:tgtEl>
+                </p:cond>
+              </p:nextCondLst>
+            </p:seq>
+          </p:childTnLst>
+        </p:cTn>
+      </p:par>
+    </p:tnLst>
+  </p:timing>
 </p:sld>
 </file>
 
@@ -36830,6 +41317,174 @@
   <p:clrMapOvr>
     <a:masterClrMapping/>
   </p:clrMapOvr>
+  <mc:AlternateContent xmlns:mc="http://schemas.openxmlformats.org/markup-compatibility/2006">
+    <mc:Choice xmlns:p14="http://schemas.microsoft.com/office/powerpoint/2010/main" Requires="p14">
+      <p:transition spd="med" p14:dur="700">
+        <p:fade/>
+      </p:transition>
+    </mc:Choice>
+    <mc:Fallback>
+      <p:transition spd="med">
+        <p:fade/>
+      </p:transition>
+    </mc:Fallback>
+  </mc:AlternateContent>
+  <p:timing>
+    <p:tnLst>
+      <p:par>
+        <p:cTn id="1" dur="indefinite" restart="never" nodeType="tmRoot">
+          <p:childTnLst>
+            <p:seq concurrent="1" nextAc="seek">
+              <p:cTn id="2" dur="indefinite" nodeType="mainSeq">
+                <p:childTnLst>
+                  <p:par>
+                    <p:cTn id="3" fill="hold">
+                      <p:stCondLst>
+                        <p:cond delay="indefinite"/>
+                        <p:cond evt="onBegin" delay="0">
+                          <p:tn val="2"/>
+                        </p:cond>
+                      </p:stCondLst>
+                      <p:childTnLst>
+                        <p:par>
+                          <p:cTn id="4" fill="hold">
+                            <p:stCondLst>
+                              <p:cond delay="0"/>
+                            </p:stCondLst>
+                            <p:childTnLst>
+                              <p:par>
+                                <p:cTn id="5" presetID="10" presetClass="entr" presetSubtype="0" fill="hold" nodeType="afterEffect">
+                                  <p:stCondLst>
+                                    <p:cond delay="0"/>
+                                  </p:stCondLst>
+                                  <p:childTnLst>
+                                    <p:set>
+                                      <p:cBhvr>
+                                        <p:cTn id="6" dur="1" fill="hold">
+                                          <p:stCondLst>
+                                            <p:cond delay="0"/>
+                                          </p:stCondLst>
+                                        </p:cTn>
+                                        <p:tgtEl>
+                                          <p:spTgt spid="4"/>
+                                        </p:tgtEl>
+                                        <p:attrNameLst>
+                                          <p:attrName>style.visibility</p:attrName>
+                                        </p:attrNameLst>
+                                      </p:cBhvr>
+                                      <p:to>
+                                        <p:strVal val="visible"/>
+                                      </p:to>
+                                    </p:set>
+                                    <p:animEffect transition="in" filter="fade">
+                                      <p:cBhvr>
+                                        <p:cTn id="7" dur="500"/>
+                                        <p:tgtEl>
+                                          <p:spTgt spid="4"/>
+                                        </p:tgtEl>
+                                      </p:cBhvr>
+                                    </p:animEffect>
+                                  </p:childTnLst>
+                                </p:cTn>
+                              </p:par>
+                              <p:par>
+                                <p:cTn id="8" presetID="10" presetClass="entr" presetSubtype="0" fill="hold" nodeType="withEffect">
+                                  <p:stCondLst>
+                                    <p:cond delay="300"/>
+                                  </p:stCondLst>
+                                  <p:childTnLst>
+                                    <p:set>
+                                      <p:cBhvr>
+                                        <p:cTn id="9" dur="1" fill="hold">
+                                          <p:stCondLst>
+                                            <p:cond delay="0"/>
+                                          </p:stCondLst>
+                                        </p:cTn>
+                                        <p:tgtEl>
+                                          <p:spTgt spid="26"/>
+                                        </p:tgtEl>
+                                        <p:attrNameLst>
+                                          <p:attrName>style.visibility</p:attrName>
+                                        </p:attrNameLst>
+                                      </p:cBhvr>
+                                      <p:to>
+                                        <p:strVal val="visible"/>
+                                      </p:to>
+                                    </p:set>
+                                    <p:animEffect transition="in" filter="fade">
+                                      <p:cBhvr>
+                                        <p:cTn id="10" dur="500"/>
+                                        <p:tgtEl>
+                                          <p:spTgt spid="26"/>
+                                        </p:tgtEl>
+                                      </p:cBhvr>
+                                    </p:animEffect>
+                                  </p:childTnLst>
+                                </p:cTn>
+                              </p:par>
+                              <p:par>
+                                <p:cTn id="11" presetID="10" presetClass="entr" presetSubtype="0" fill="hold" nodeType="withEffect">
+                                  <p:stCondLst>
+                                    <p:cond delay="600"/>
+                                  </p:stCondLst>
+                                  <p:childTnLst>
+                                    <p:set>
+                                      <p:cBhvr>
+                                        <p:cTn id="12" dur="1" fill="hold">
+                                          <p:stCondLst>
+                                            <p:cond delay="0"/>
+                                          </p:stCondLst>
+                                        </p:cTn>
+                                        <p:tgtEl>
+                                          <p:spTgt spid="27"/>
+                                        </p:tgtEl>
+                                        <p:attrNameLst>
+                                          <p:attrName>style.visibility</p:attrName>
+                                        </p:attrNameLst>
+                                      </p:cBhvr>
+                                      <p:to>
+                                        <p:strVal val="visible"/>
+                                      </p:to>
+                                    </p:set>
+                                    <p:animEffect transition="in" filter="fade">
+                                      <p:cBhvr>
+                                        <p:cTn id="13" dur="500"/>
+                                        <p:tgtEl>
+                                          <p:spTgt spid="27"/>
+                                        </p:tgtEl>
+                                      </p:cBhvr>
+                                    </p:animEffect>
+                                  </p:childTnLst>
+                                </p:cTn>
+                              </p:par>
+                            </p:childTnLst>
+                          </p:cTn>
+                        </p:par>
+                      </p:childTnLst>
+                    </p:cTn>
+                  </p:par>
+                </p:childTnLst>
+              </p:cTn>
+              <p:prevCondLst>
+                <p:cond evt="onPrev" delay="0">
+                  <p:tgtEl>
+                    <p:sldTgt/>
+                  </p:tgtEl>
+                </p:cond>
+              </p:prevCondLst>
+              <p:nextCondLst>
+                <p:cond evt="onNext" delay="0">
+                  <p:tgtEl>
+                    <p:sldTgt/>
+                  </p:tgtEl>
+                </p:cond>
+              </p:nextCondLst>
+            </p:seq>
+          </p:childTnLst>
+        </p:cTn>
+      </p:par>
+    </p:tnLst>
+  </p:timing>
 </p:sld>
 </file>
 

</xml_diff>